<commit_message>
run campaign 4 with original teda and document findings
</commit_message>
<xml_diff>
--- a/docs/meeting/2026-03-19-advisor-meeting.pptx
+++ b/docs/meeting/2026-03-19-advisor-meeting.pptx
@@ -17,6 +17,7 @@
     <p:sldId id="265" r:id="rId16"/>
     <p:sldId id="266" r:id="rId17"/>
     <p:sldId id="267" r:id="rId18"/>
+    <p:sldId id="268" r:id="rId19"/>
   </p:sldIdLst>
   <p:sldSz cx="12191695" cy="6858000" type="screen4x3"/>
   <p:notesSz cx="6858000" cy="9144000"/>
@@ -3246,7 +3247,7 @@
               </a:defRPr>
             </a:pPr>
             <a:r>
-              <a:t>137 experimentos | 3 campanhas | 4 steps de ablation</a:t>
+              <a:t>167 experimentos | 4 campanhas | 5 steps de ablation</a:t>
             </a:r>
           </a:p>
         </p:txBody>
@@ -3351,21 +3352,972 @@
               </a:defRPr>
             </a:pPr>
             <a:r>
-              <a:t>5 Insights Principais</a:t>
-            </a:r>
-          </a:p>
-        </p:txBody>
-      </p:sp>
-      <p:sp>
-        <p:nvSpPr>
-          <p:cNvPr id="4" name="TextBox 3"/>
+              <a:t>Consolidado — Melhor Resultado por Ataque</a:t>
+            </a:r>
+          </a:p>
+        </p:txBody>
+      </p:sp>
+      <p:graphicFrame>
+        <p:nvGraphicFramePr>
+          <p:cNvPr id="4" name="Table 3"/>
+          <p:cNvGraphicFramePr>
+            <a:graphicFrameLocks noGrp="1"/>
+          </p:cNvGraphicFramePr>
+          <p:nvPr/>
+        </p:nvGraphicFramePr>
+        <p:xfrm>
+          <a:off x="457200" y="1371600"/>
+          <a:ext cx="11247120" cy="3200400"/>
+        </p:xfrm>
+        <a:graphic>
+          <a:graphicData uri="http://schemas.openxmlformats.org/drawingml/2006/table">
+            <a:tbl>
+              <a:tblPr firstRow="1" bandRow="1">
+                <a:tableStyleId>{5C22544A-7EE6-4342-B048-85BDC9FD1C3A}</a:tableStyleId>
+              </a:tblPr>
+              <a:tblGrid>
+                <a:gridCol w="1874520"/>
+                <a:gridCol w="1874520"/>
+                <a:gridCol w="1874520"/>
+                <a:gridCol w="1874520"/>
+                <a:gridCol w="1874520"/>
+                <a:gridCol w="1874520"/>
+              </a:tblGrid>
+              <a:tr h="457200">
+                <a:tc>
+                  <a:txBody>
+                    <a:bodyPr/>
+                    <a:lstStyle/>
+                    <a:p>
+                      <a:pPr>
+                        <a:defRPr b="1" sz="1400">
+                          <a:solidFill>
+                            <a:srgbClr val="FFFFFF"/>
+                          </a:solidFill>
+                          <a:latin typeface="Calibri"/>
+                        </a:defRPr>
+                      </a:pPr>
+                      <a:r>
+                        <a:t>Ataque</a:t>
+                      </a:r>
+                    </a:p>
+                  </a:txBody>
+                  <a:tcPr>
+                    <a:solidFill>
+                      <a:srgbClr val="1B3A5C"/>
+                    </a:solidFill>
+                  </a:tcPr>
+                </a:tc>
+                <a:tc>
+                  <a:txBody>
+                    <a:bodyPr/>
+                    <a:lstStyle/>
+                    <a:p>
+                      <a:pPr>
+                        <a:defRPr b="1" sz="1400">
+                          <a:solidFill>
+                            <a:srgbClr val="FFFFFF"/>
+                          </a:solidFill>
+                          <a:latin typeface="Calibri"/>
+                        </a:defRPr>
+                      </a:pPr>
+                      <a:r>
+                        <a:t>Campanha</a:t>
+                      </a:r>
+                    </a:p>
+                  </a:txBody>
+                  <a:tcPr>
+                    <a:solidFill>
+                      <a:srgbClr val="1B3A5C"/>
+                    </a:solidFill>
+                  </a:tcPr>
+                </a:tc>
+                <a:tc>
+                  <a:txBody>
+                    <a:bodyPr/>
+                    <a:lstStyle/>
+                    <a:p>
+                      <a:pPr>
+                        <a:defRPr b="1" sz="1400">
+                          <a:solidFill>
+                            <a:srgbClr val="FFFFFF"/>
+                          </a:solidFill>
+                          <a:latin typeface="Calibri"/>
+                        </a:defRPr>
+                      </a:pPr>
+                      <a:r>
+                        <a:t>Config</a:t>
+                      </a:r>
+                    </a:p>
+                  </a:txBody>
+                  <a:tcPr>
+                    <a:solidFill>
+                      <a:srgbClr val="1B3A5C"/>
+                    </a:solidFill>
+                  </a:tcPr>
+                </a:tc>
+                <a:tc>
+                  <a:txBody>
+                    <a:bodyPr/>
+                    <a:lstStyle/>
+                    <a:p>
+                      <a:pPr>
+                        <a:defRPr b="1" sz="1400">
+                          <a:solidFill>
+                            <a:srgbClr val="FFFFFF"/>
+                          </a:solidFill>
+                          <a:latin typeface="Calibri"/>
+                        </a:defRPr>
+                      </a:pPr>
+                      <a:r>
+                        <a:t>Recall</a:t>
+                      </a:r>
+                    </a:p>
+                  </a:txBody>
+                  <a:tcPr>
+                    <a:solidFill>
+                      <a:srgbClr val="1B3A5C"/>
+                    </a:solidFill>
+                  </a:tcPr>
+                </a:tc>
+                <a:tc>
+                  <a:txBody>
+                    <a:bodyPr/>
+                    <a:lstStyle/>
+                    <a:p>
+                      <a:pPr>
+                        <a:defRPr b="1" sz="1400">
+                          <a:solidFill>
+                            <a:srgbClr val="FFFFFF"/>
+                          </a:solidFill>
+                          <a:latin typeface="Calibri"/>
+                        </a:defRPr>
+                      </a:pPr>
+                      <a:r>
+                        <a:t>F1</a:t>
+                      </a:r>
+                    </a:p>
+                  </a:txBody>
+                  <a:tcPr>
+                    <a:solidFill>
+                      <a:srgbClr val="1B3A5C"/>
+                    </a:solidFill>
+                  </a:tcPr>
+                </a:tc>
+                <a:tc>
+                  <a:txBody>
+                    <a:bodyPr/>
+                    <a:lstStyle/>
+                    <a:p>
+                      <a:pPr>
+                        <a:defRPr b="1" sz="1400">
+                          <a:solidFill>
+                            <a:srgbClr val="FFFFFF"/>
+                          </a:solidFill>
+                          <a:latin typeface="Calibri"/>
+                        </a:defRPr>
+                      </a:pPr>
+                      <a:r>
+                        <a:t>FPR</a:t>
+                      </a:r>
+                    </a:p>
+                  </a:txBody>
+                  <a:tcPr>
+                    <a:solidFill>
+                      <a:srgbClr val="1B3A5C"/>
+                    </a:solidFill>
+                  </a:tcPr>
+                </a:tc>
+              </a:tr>
+              <a:tr h="457200">
+                <a:tc>
+                  <a:txBody>
+                    <a:bodyPr/>
+                    <a:lstStyle/>
+                    <a:p>
+                      <a:pPr algn="ctr">
+                        <a:defRPr sz="1300" b="0">
+                          <a:solidFill>
+                            <a:srgbClr val="000000"/>
+                          </a:solidFill>
+                          <a:latin typeface="Calibri"/>
+                        </a:defRPr>
+                      </a:pPr>
+                      <a:r>
+                        <a:t>DDoS-ICMP</a:t>
+                      </a:r>
+                    </a:p>
+                  </a:txBody>
+                  <a:tcPr anchor="ctr"/>
+                </a:tc>
+                <a:tc>
+                  <a:txBody>
+                    <a:bodyPr/>
+                    <a:lstStyle/>
+                    <a:p>
+                      <a:pPr algn="ctr">
+                        <a:defRPr sz="1300" b="0">
+                          <a:solidFill>
+                            <a:srgbClr val="000000"/>
+                          </a:solidFill>
+                          <a:latin typeface="Calibri"/>
+                        </a:defRPr>
+                      </a:pPr>
+                      <a:r>
+                        <a:t>C03-S4</a:t>
+                      </a:r>
+                    </a:p>
+                  </a:txBody>
+                  <a:tcPr anchor="ctr"/>
+                </a:tc>
+                <a:tc>
+                  <a:txBody>
+                    <a:bodyPr/>
+                    <a:lstStyle/>
+                    <a:p>
+                      <a:pPr algn="ctr">
+                        <a:defRPr sz="1300" b="0">
+                          <a:solidFill>
+                            <a:srgbClr val="000000"/>
+                          </a:solidFill>
+                          <a:latin typeface="Calibri"/>
+                        </a:defRPr>
+                      </a:pPr>
+                      <a:r>
+                        <a:t>v2 / w10s / r0=0.10</a:t>
+                      </a:r>
+                    </a:p>
+                  </a:txBody>
+                  <a:tcPr anchor="ctr"/>
+                </a:tc>
+                <a:tc>
+                  <a:txBody>
+                    <a:bodyPr/>
+                    <a:lstStyle/>
+                    <a:p>
+                      <a:pPr algn="ctr">
+                        <a:defRPr sz="1300" b="0">
+                          <a:solidFill>
+                            <a:srgbClr val="000000"/>
+                          </a:solidFill>
+                          <a:latin typeface="Calibri"/>
+                        </a:defRPr>
+                      </a:pPr>
+                      <a:r>
+                        <a:t>50.0%</a:t>
+                      </a:r>
+                    </a:p>
+                  </a:txBody>
+                  <a:tcPr anchor="ctr"/>
+                </a:tc>
+                <a:tc>
+                  <a:txBody>
+                    <a:bodyPr/>
+                    <a:lstStyle/>
+                    <a:p>
+                      <a:pPr algn="ctr">
+                        <a:defRPr sz="1300" b="0">
+                          <a:solidFill>
+                            <a:srgbClr val="000000"/>
+                          </a:solidFill>
+                          <a:latin typeface="Calibri"/>
+                        </a:defRPr>
+                      </a:pPr>
+                      <a:r>
+                        <a:t>5.6%</a:t>
+                      </a:r>
+                    </a:p>
+                  </a:txBody>
+                  <a:tcPr anchor="ctr"/>
+                </a:tc>
+                <a:tc>
+                  <a:txBody>
+                    <a:bodyPr/>
+                    <a:lstStyle/>
+                    <a:p>
+                      <a:pPr algn="ctr">
+                        <a:defRPr sz="1300" b="0">
+                          <a:solidFill>
+                            <a:srgbClr val="000000"/>
+                          </a:solidFill>
+                          <a:latin typeface="Calibri"/>
+                        </a:defRPr>
+                      </a:pPr>
+                      <a:r>
+                        <a:t>15.7%</a:t>
+                      </a:r>
+                    </a:p>
+                  </a:txBody>
+                  <a:tcPr anchor="ctr"/>
+                </a:tc>
+              </a:tr>
+              <a:tr h="457200">
+                <a:tc>
+                  <a:txBody>
+                    <a:bodyPr/>
+                    <a:lstStyle/>
+                    <a:p>
+                      <a:pPr algn="ctr">
+                        <a:defRPr sz="1300" b="0">
+                          <a:solidFill>
+                            <a:srgbClr val="000000"/>
+                          </a:solidFill>
+                          <a:latin typeface="Calibri"/>
+                        </a:defRPr>
+                      </a:pPr>
+                      <a:r>
+                        <a:t>DDoS-SYN</a:t>
+                      </a:r>
+                    </a:p>
+                  </a:txBody>
+                  <a:tcPr anchor="ctr"/>
+                </a:tc>
+                <a:tc>
+                  <a:txBody>
+                    <a:bodyPr/>
+                    <a:lstStyle/>
+                    <a:p>
+                      <a:pPr algn="ctr">
+                        <a:defRPr sz="1300" b="0">
+                          <a:solidFill>
+                            <a:srgbClr val="000000"/>
+                          </a:solidFill>
+                          <a:latin typeface="Calibri"/>
+                        </a:defRPr>
+                      </a:pPr>
+                      <a:r>
+                        <a:t>C03-S4</a:t>
+                      </a:r>
+                    </a:p>
+                  </a:txBody>
+                  <a:tcPr anchor="ctr"/>
+                </a:tc>
+                <a:tc>
+                  <a:txBody>
+                    <a:bodyPr/>
+                    <a:lstStyle/>
+                    <a:p>
+                      <a:pPr algn="ctr">
+                        <a:defRPr sz="1300" b="0">
+                          <a:solidFill>
+                            <a:srgbClr val="000000"/>
+                          </a:solidFill>
+                          <a:latin typeface="Calibri"/>
+                        </a:defRPr>
+                      </a:pPr>
+                      <a:r>
+                        <a:t>v2 / w30s / r0=0.05</a:t>
+                      </a:r>
+                    </a:p>
+                  </a:txBody>
+                  <a:tcPr anchor="ctr"/>
+                </a:tc>
+                <a:tc>
+                  <a:txBody>
+                    <a:bodyPr/>
+                    <a:lstStyle/>
+                    <a:p>
+                      <a:pPr algn="ctr">
+                        <a:defRPr sz="1300" b="0">
+                          <a:solidFill>
+                            <a:srgbClr val="000000"/>
+                          </a:solidFill>
+                          <a:latin typeface="Calibri"/>
+                        </a:defRPr>
+                      </a:pPr>
+                      <a:r>
+                        <a:t>61.5%</a:t>
+                      </a:r>
+                    </a:p>
+                  </a:txBody>
+                  <a:tcPr anchor="ctr"/>
+                </a:tc>
+                <a:tc>
+                  <a:txBody>
+                    <a:bodyPr/>
+                    <a:lstStyle/>
+                    <a:p>
+                      <a:pPr algn="ctr">
+                        <a:defRPr sz="1300" b="0">
+                          <a:solidFill>
+                            <a:srgbClr val="000000"/>
+                          </a:solidFill>
+                          <a:latin typeface="Calibri"/>
+                        </a:defRPr>
+                      </a:pPr>
+                      <a:r>
+                        <a:t>21.6%</a:t>
+                      </a:r>
+                    </a:p>
+                  </a:txBody>
+                  <a:tcPr anchor="ctr"/>
+                </a:tc>
+                <a:tc>
+                  <a:txBody>
+                    <a:bodyPr/>
+                    <a:lstStyle/>
+                    <a:p>
+                      <a:pPr algn="ctr">
+                        <a:defRPr sz="1300" b="0">
+                          <a:solidFill>
+                            <a:srgbClr val="000000"/>
+                          </a:solidFill>
+                          <a:latin typeface="Calibri"/>
+                        </a:defRPr>
+                      </a:pPr>
+                      <a:r>
+                        <a:t>36.1%</a:t>
+                      </a:r>
+                    </a:p>
+                  </a:txBody>
+                  <a:tcPr anchor="ctr"/>
+                </a:tc>
+              </a:tr>
+              <a:tr h="457200">
+                <a:tc>
+                  <a:txBody>
+                    <a:bodyPr/>
+                    <a:lstStyle/>
+                    <a:p>
+                      <a:pPr algn="ctr">
+                        <a:defRPr sz="1300" b="0">
+                          <a:solidFill>
+                            <a:srgbClr val="000000"/>
+                          </a:solidFill>
+                          <a:latin typeface="Calibri"/>
+                        </a:defRPr>
+                      </a:pPr>
+                      <a:r>
+                        <a:t>DDoS-TCP</a:t>
+                      </a:r>
+                    </a:p>
+                  </a:txBody>
+                  <a:tcPr anchor="ctr"/>
+                </a:tc>
+                <a:tc>
+                  <a:txBody>
+                    <a:bodyPr/>
+                    <a:lstStyle/>
+                    <a:p>
+                      <a:pPr algn="ctr">
+                        <a:defRPr sz="1300" b="0">
+                          <a:solidFill>
+                            <a:srgbClr val="000000"/>
+                          </a:solidFill>
+                          <a:latin typeface="Calibri"/>
+                        </a:defRPr>
+                      </a:pPr>
+                      <a:r>
+                        <a:t>—</a:t>
+                      </a:r>
+                    </a:p>
+                  </a:txBody>
+                  <a:tcPr anchor="ctr"/>
+                </a:tc>
+                <a:tc>
+                  <a:txBody>
+                    <a:bodyPr/>
+                    <a:lstStyle/>
+                    <a:p>
+                      <a:pPr algn="ctr">
+                        <a:defRPr sz="1300" b="0">
+                          <a:solidFill>
+                            <a:srgbClr val="E74C3C"/>
+                          </a:solidFill>
+                          <a:latin typeface="Calibri"/>
+                        </a:defRPr>
+                      </a:pPr>
+                      <a:r>
+                        <a:t>Indetectável</a:t>
+                      </a:r>
+                    </a:p>
+                  </a:txBody>
+                  <a:tcPr anchor="ctr"/>
+                </a:tc>
+                <a:tc>
+                  <a:txBody>
+                    <a:bodyPr/>
+                    <a:lstStyle/>
+                    <a:p>
+                      <a:pPr algn="ctr">
+                        <a:defRPr sz="1300" b="0">
+                          <a:solidFill>
+                            <a:srgbClr val="E74C3C"/>
+                          </a:solidFill>
+                          <a:latin typeface="Calibri"/>
+                        </a:defRPr>
+                      </a:pPr>
+                      <a:r>
+                        <a:t>0.0%</a:t>
+                      </a:r>
+                    </a:p>
+                  </a:txBody>
+                  <a:tcPr anchor="ctr"/>
+                </a:tc>
+                <a:tc>
+                  <a:txBody>
+                    <a:bodyPr/>
+                    <a:lstStyle/>
+                    <a:p>
+                      <a:pPr algn="ctr">
+                        <a:defRPr sz="1300" b="0">
+                          <a:solidFill>
+                            <a:srgbClr val="E74C3C"/>
+                          </a:solidFill>
+                          <a:latin typeface="Calibri"/>
+                        </a:defRPr>
+                      </a:pPr>
+                      <a:r>
+                        <a:t>0.0%</a:t>
+                      </a:r>
+                    </a:p>
+                  </a:txBody>
+                  <a:tcPr anchor="ctr"/>
+                </a:tc>
+                <a:tc>
+                  <a:txBody>
+                    <a:bodyPr/>
+                    <a:lstStyle/>
+                    <a:p>
+                      <a:pPr algn="ctr">
+                        <a:defRPr sz="1300" b="0">
+                          <a:solidFill>
+                            <a:srgbClr val="000000"/>
+                          </a:solidFill>
+                          <a:latin typeface="Calibri"/>
+                        </a:defRPr>
+                      </a:pPr>
+                      <a:r>
+                        <a:t>—</a:t>
+                      </a:r>
+                    </a:p>
+                  </a:txBody>
+                  <a:tcPr anchor="ctr"/>
+                </a:tc>
+              </a:tr>
+              <a:tr h="457200">
+                <a:tc>
+                  <a:txBody>
+                    <a:bodyPr/>
+                    <a:lstStyle/>
+                    <a:p>
+                      <a:pPr algn="ctr">
+                        <a:defRPr sz="1300" b="0">
+                          <a:solidFill>
+                            <a:srgbClr val="000000"/>
+                          </a:solidFill>
+                          <a:latin typeface="Calibri"/>
+                        </a:defRPr>
+                      </a:pPr>
+                      <a:r>
+                        <a:t>Mirai</a:t>
+                      </a:r>
+                    </a:p>
+                  </a:txBody>
+                  <a:tcPr anchor="ctr"/>
+                </a:tc>
+                <a:tc>
+                  <a:txBody>
+                    <a:bodyPr/>
+                    <a:lstStyle/>
+                    <a:p>
+                      <a:pPr algn="ctr">
+                        <a:defRPr sz="1300" b="0">
+                          <a:solidFill>
+                            <a:srgbClr val="000000"/>
+                          </a:solidFill>
+                          <a:latin typeface="Calibri"/>
+                        </a:defRPr>
+                      </a:pPr>
+                      <a:r>
+                        <a:t>C03-S4</a:t>
+                      </a:r>
+                    </a:p>
+                  </a:txBody>
+                  <a:tcPr anchor="ctr"/>
+                </a:tc>
+                <a:tc>
+                  <a:txBody>
+                    <a:bodyPr/>
+                    <a:lstStyle/>
+                    <a:p>
+                      <a:pPr algn="ctr">
+                        <a:defRPr sz="1300" b="0">
+                          <a:solidFill>
+                            <a:srgbClr val="000000"/>
+                          </a:solidFill>
+                          <a:latin typeface="Calibri"/>
+                        </a:defRPr>
+                      </a:pPr>
+                      <a:r>
+                        <a:t>v1 / w10s / r0=0.10</a:t>
+                      </a:r>
+                    </a:p>
+                  </a:txBody>
+                  <a:tcPr anchor="ctr"/>
+                </a:tc>
+                <a:tc>
+                  <a:txBody>
+                    <a:bodyPr/>
+                    <a:lstStyle/>
+                    <a:p>
+                      <a:pPr algn="ctr">
+                        <a:defRPr sz="1300" b="0">
+                          <a:solidFill>
+                            <a:srgbClr val="000000"/>
+                          </a:solidFill>
+                          <a:latin typeface="Calibri"/>
+                        </a:defRPr>
+                      </a:pPr>
+                      <a:r>
+                        <a:t>46.2%</a:t>
+                      </a:r>
+                    </a:p>
+                  </a:txBody>
+                  <a:tcPr anchor="ctr"/>
+                </a:tc>
+                <a:tc>
+                  <a:txBody>
+                    <a:bodyPr/>
+                    <a:lstStyle/>
+                    <a:p>
+                      <a:pPr algn="ctr">
+                        <a:defRPr sz="1300" b="0">
+                          <a:solidFill>
+                            <a:srgbClr val="000000"/>
+                          </a:solidFill>
+                          <a:latin typeface="Calibri"/>
+                        </a:defRPr>
+                      </a:pPr>
+                      <a:r>
+                        <a:t>23.1%</a:t>
+                      </a:r>
+                    </a:p>
+                  </a:txBody>
+                  <a:tcPr anchor="ctr"/>
+                </a:tc>
+                <a:tc>
+                  <a:txBody>
+                    <a:bodyPr/>
+                    <a:lstStyle/>
+                    <a:p>
+                      <a:pPr algn="ctr">
+                        <a:defRPr sz="1300" b="0">
+                          <a:solidFill>
+                            <a:srgbClr val="000000"/>
+                          </a:solidFill>
+                          <a:latin typeface="Calibri"/>
+                        </a:defRPr>
+                      </a:pPr>
+                      <a:r>
+                        <a:t>15.5%</a:t>
+                      </a:r>
+                    </a:p>
+                  </a:txBody>
+                  <a:tcPr anchor="ctr"/>
+                </a:tc>
+              </a:tr>
+              <a:tr h="457200">
+                <a:tc>
+                  <a:txBody>
+                    <a:bodyPr/>
+                    <a:lstStyle/>
+                    <a:p>
+                      <a:pPr algn="ctr">
+                        <a:defRPr sz="1300" b="1">
+                          <a:solidFill>
+                            <a:srgbClr val="000000"/>
+                          </a:solidFill>
+                          <a:latin typeface="Calibri"/>
+                        </a:defRPr>
+                      </a:pPr>
+                      <a:r>
+                        <a:t>Recon</a:t>
+                      </a:r>
+                    </a:p>
+                  </a:txBody>
+                  <a:tcPr anchor="ctr"/>
+                </a:tc>
+                <a:tc>
+                  <a:txBody>
+                    <a:bodyPr/>
+                    <a:lstStyle/>
+                    <a:p>
+                      <a:pPr algn="ctr">
+                        <a:defRPr sz="1300" b="1">
+                          <a:solidFill>
+                            <a:srgbClr val="000000"/>
+                          </a:solidFill>
+                          <a:latin typeface="Calibri"/>
+                        </a:defRPr>
+                      </a:pPr>
+                      <a:r>
+                        <a:t>C03-S4</a:t>
+                      </a:r>
+                    </a:p>
+                  </a:txBody>
+                  <a:tcPr anchor="ctr"/>
+                </a:tc>
+                <a:tc>
+                  <a:txBody>
+                    <a:bodyPr/>
+                    <a:lstStyle/>
+                    <a:p>
+                      <a:pPr algn="ctr">
+                        <a:defRPr sz="1300" b="1">
+                          <a:solidFill>
+                            <a:srgbClr val="000000"/>
+                          </a:solidFill>
+                          <a:latin typeface="Calibri"/>
+                        </a:defRPr>
+                      </a:pPr>
+                      <a:r>
+                        <a:t>v2 / w10s / r0=0.05</a:t>
+                      </a:r>
+                    </a:p>
+                  </a:txBody>
+                  <a:tcPr anchor="ctr"/>
+                </a:tc>
+                <a:tc>
+                  <a:txBody>
+                    <a:bodyPr/>
+                    <a:lstStyle/>
+                    <a:p>
+                      <a:pPr algn="ctr">
+                        <a:defRPr sz="1300" b="1">
+                          <a:solidFill>
+                            <a:srgbClr val="000000"/>
+                          </a:solidFill>
+                          <a:latin typeface="Calibri"/>
+                        </a:defRPr>
+                      </a:pPr>
+                      <a:r>
+                        <a:t>49.1%</a:t>
+                      </a:r>
+                    </a:p>
+                  </a:txBody>
+                  <a:tcPr anchor="ctr"/>
+                </a:tc>
+                <a:tc>
+                  <a:txBody>
+                    <a:bodyPr/>
+                    <a:lstStyle/>
+                    <a:p>
+                      <a:pPr algn="ctr">
+                        <a:defRPr sz="1300" b="1">
+                          <a:solidFill>
+                            <a:srgbClr val="27AE60"/>
+                          </a:solidFill>
+                          <a:latin typeface="Calibri"/>
+                        </a:defRPr>
+                      </a:pPr>
+                      <a:r>
+                        <a:t>43.7%</a:t>
+                      </a:r>
+                    </a:p>
+                  </a:txBody>
+                  <a:tcPr anchor="ctr"/>
+                </a:tc>
+                <a:tc>
+                  <a:txBody>
+                    <a:bodyPr/>
+                    <a:lstStyle/>
+                    <a:p>
+                      <a:pPr algn="ctr">
+                        <a:defRPr sz="1300" b="1">
+                          <a:solidFill>
+                            <a:srgbClr val="000000"/>
+                          </a:solidFill>
+                          <a:latin typeface="Calibri"/>
+                        </a:defRPr>
+                      </a:pPr>
+                      <a:r>
+                        <a:t>12.9%</a:t>
+                      </a:r>
+                    </a:p>
+                  </a:txBody>
+                  <a:tcPr anchor="ctr"/>
+                </a:tc>
+              </a:tr>
+              <a:tr h="457200">
+                <a:tc>
+                  <a:txBody>
+                    <a:bodyPr/>
+                    <a:lstStyle/>
+                    <a:p>
+                      <a:pPr algn="ctr">
+                        <a:defRPr sz="1300" b="0">
+                          <a:solidFill>
+                            <a:srgbClr val="000000"/>
+                          </a:solidFill>
+                          <a:latin typeface="Calibri"/>
+                        </a:defRPr>
+                      </a:pPr>
+                      <a:r>
+                        <a:t>Benigno (FPR)</a:t>
+                      </a:r>
+                    </a:p>
+                  </a:txBody>
+                  <a:tcPr anchor="ctr"/>
+                </a:tc>
+                <a:tc>
+                  <a:txBody>
+                    <a:bodyPr/>
+                    <a:lstStyle/>
+                    <a:p>
+                      <a:pPr algn="ctr">
+                        <a:defRPr sz="1300" b="0">
+                          <a:solidFill>
+                            <a:srgbClr val="000000"/>
+                          </a:solidFill>
+                          <a:latin typeface="Calibri"/>
+                        </a:defRPr>
+                      </a:pPr>
+                      <a:r>
+                        <a:t>C02-S1</a:t>
+                      </a:r>
+                    </a:p>
+                  </a:txBody>
+                  <a:tcPr anchor="ctr"/>
+                </a:tc>
+                <a:tc>
+                  <a:txBody>
+                    <a:bodyPr/>
+                    <a:lstStyle/>
+                    <a:p>
+                      <a:pPr algn="ctr">
+                        <a:defRPr sz="1300" b="0">
+                          <a:solidFill>
+                            <a:srgbClr val="000000"/>
+                          </a:solidFill>
+                          <a:latin typeface="Calibri"/>
+                        </a:defRPr>
+                      </a:pPr>
+                      <a:r>
+                        <a:t>flow-level / r0=0.10</a:t>
+                      </a:r>
+                    </a:p>
+                  </a:txBody>
+                  <a:tcPr anchor="ctr"/>
+                </a:tc>
+                <a:tc>
+                  <a:txBody>
+                    <a:bodyPr/>
+                    <a:lstStyle/>
+                    <a:p>
+                      <a:pPr algn="ctr">
+                        <a:defRPr sz="1300" b="0">
+                          <a:solidFill>
+                            <a:srgbClr val="000000"/>
+                          </a:solidFill>
+                          <a:latin typeface="Calibri"/>
+                        </a:defRPr>
+                      </a:pPr>
+                      <a:r>
+                        <a:t>—</a:t>
+                      </a:r>
+                    </a:p>
+                  </a:txBody>
+                  <a:tcPr anchor="ctr"/>
+                </a:tc>
+                <a:tc>
+                  <a:txBody>
+                    <a:bodyPr/>
+                    <a:lstStyle/>
+                    <a:p>
+                      <a:pPr algn="ctr">
+                        <a:defRPr sz="1300" b="0">
+                          <a:solidFill>
+                            <a:srgbClr val="000000"/>
+                          </a:solidFill>
+                          <a:latin typeface="Calibri"/>
+                        </a:defRPr>
+                      </a:pPr>
+                      <a:r>
+                        <a:t>—</a:t>
+                      </a:r>
+                    </a:p>
+                  </a:txBody>
+                  <a:tcPr anchor="ctr"/>
+                </a:tc>
+                <a:tc>
+                  <a:txBody>
+                    <a:bodyPr/>
+                    <a:lstStyle/>
+                    <a:p>
+                      <a:pPr algn="ctr">
+                        <a:defRPr sz="1300" b="0">
+                          <a:solidFill>
+                            <a:srgbClr val="000000"/>
+                          </a:solidFill>
+                          <a:latin typeface="Calibri"/>
+                        </a:defRPr>
+                      </a:pPr>
+                      <a:r>
+                        <a:t>3.5%</a:t>
+                      </a:r>
+                    </a:p>
+                  </a:txBody>
+                  <a:tcPr anchor="ctr"/>
+                </a:tc>
+              </a:tr>
+            </a:tbl>
+          </a:graphicData>
+        </a:graphic>
+      </p:graphicFrame>
+      <p:sp>
+        <p:nvSpPr>
+          <p:cNvPr id="5" name="Rounded Rectangle 4"/>
+          <p:cNvSpPr/>
+          <p:nvPr/>
+        </p:nvSpPr>
+        <p:spPr>
+          <a:xfrm>
+            <a:off x="457200" y="4846320"/>
+            <a:ext cx="11247120" cy="1645920"/>
+          </a:xfrm>
+          <a:prstGeom prst="roundRect">
+            <a:avLst/>
+          </a:prstGeom>
+          <a:solidFill>
+            <a:srgbClr val="E8F5E9"/>
+          </a:solidFill>
+          <a:ln>
+            <a:noFill/>
+          </a:ln>
+        </p:spPr>
+        <p:style>
+          <a:lnRef idx="1">
+            <a:schemeClr val="accent1"/>
+          </a:lnRef>
+          <a:fillRef idx="3">
+            <a:schemeClr val="accent1"/>
+          </a:fillRef>
+          <a:effectRef idx="2">
+            <a:schemeClr val="accent1"/>
+          </a:effectRef>
+          <a:fontRef idx="minor">
+            <a:schemeClr val="lt1"/>
+          </a:fontRef>
+        </p:style>
+        <p:txBody>
+          <a:bodyPr rtlCol="0" anchor="ctr"/>
+          <a:lstStyle/>
+          <a:p>
+            <a:pPr algn="ctr"/>
+          </a:p>
+        </p:txBody>
+      </p:sp>
+      <p:sp>
+        <p:nvSpPr>
+          <p:cNvPr id="6" name="TextBox 5"/>
           <p:cNvSpPr txBox="1"/>
           <p:nvPr/>
         </p:nvSpPr>
         <p:spPr>
           <a:xfrm>
-            <a:off x="457200" y="1371600"/>
-            <a:ext cx="11247120" cy="1005840"/>
+            <a:off x="731520" y="4937760"/>
+            <a:ext cx="10515600" cy="1371600"/>
           </a:xfrm>
           <a:prstGeom prst="rect">
             <a:avLst/>
@@ -3379,15 +4331,15 @@
           <a:lstStyle/>
           <a:p>
             <a:pPr algn="l">
-              <a:defRPr sz="1900" b="1">
-                <a:solidFill>
-                  <a:srgbClr val="1B3A5C"/>
-                </a:solidFill>
-                <a:latin typeface="Calibri"/>
-              </a:defRPr>
-            </a:pPr>
-            <a:r>
-              <a:t>1. Detecção per-flow é fundamentalmente limitada</a:t>
+              <a:defRPr sz="2200" b="1">
+                <a:solidFill>
+                  <a:srgbClr val="27AE60"/>
+                </a:solidFill>
+                <a:latin typeface="Calibri"/>
+              </a:defRPr>
+            </a:pPr>
+            <a:r>
+              <a:t>Destaque: Recon-PortScan F1 = 43.7%</a:t>
             </a:r>
           </a:p>
           <a:p>
@@ -3395,7 +4347,7 @@
               <a:spcBef>
                 <a:spcPts val="600"/>
               </a:spcBef>
-              <a:defRPr sz="1500" b="0">
+              <a:defRPr sz="1600" b="0">
                 <a:solidFill>
                   <a:srgbClr val="404040"/>
                 </a:solidFill>
@@ -3403,43 +4355,7 @@
               </a:defRPr>
             </a:pPr>
             <a:r>
-              <a:t>Flows de ataque DDoS são estatisticamente indistinguíveis de flows benignos IoT. Mais features per-flow (17→32) não ajudam — o problema é estrutural.</a:t>
-            </a:r>
-          </a:p>
-        </p:txBody>
-      </p:sp>
-      <p:sp>
-        <p:nvSpPr>
-          <p:cNvPr id="5" name="TextBox 4"/>
-          <p:cNvSpPr txBox="1"/>
-          <p:nvPr/>
-        </p:nvSpPr>
-        <p:spPr>
-          <a:xfrm>
-            <a:off x="457200" y="2423160"/>
-            <a:ext cx="11247120" cy="1005840"/>
-          </a:xfrm>
-          <a:prstGeom prst="rect">
-            <a:avLst/>
-          </a:prstGeom>
-          <a:noFill/>
-        </p:spPr>
-        <p:txBody>
-          <a:bodyPr wrap="square">
-            <a:spAutoFit/>
-          </a:bodyPr>
-          <a:lstStyle/>
-          <a:p>
-            <a:pPr algn="l">
-              <a:defRPr sz="1900" b="1">
-                <a:solidFill>
-                  <a:srgbClr val="1B3A5C"/>
-                </a:solidFill>
-                <a:latin typeface="Calibri"/>
-              </a:defRPr>
-            </a:pPr>
-            <a:r>
-              <a:t>2. Janelas temporais são a direção certa</a:t>
+              <a:t>Melhor resultado não-supervisionado da dissertação (Recall 49.1%, Precision 39.4%)</a:t>
             </a:r>
           </a:p>
           <a:p>
@@ -3447,7 +4363,7 @@
               <a:spcBef>
                 <a:spcPts val="600"/>
               </a:spcBef>
-              <a:defRPr sz="1500" b="0">
+              <a:defRPr sz="1600" b="0">
                 <a:solidFill>
                   <a:srgbClr val="404040"/>
                 </a:solidFill>
@@ -3455,163 +4371,7 @@
               </a:defRPr>
             </a:pPr>
             <a:r>
-              <a:t>Mudam a pergunta de "este flow é anômalo?" para "este IP tem comportamento anômalo?". Melhorias de 10-20x no Recall.</a:t>
-            </a:r>
-          </a:p>
-        </p:txBody>
-      </p:sp>
-      <p:sp>
-        <p:nvSpPr>
-          <p:cNvPr id="6" name="TextBox 5"/>
-          <p:cNvSpPr txBox="1"/>
-          <p:nvPr/>
-        </p:nvSpPr>
-        <p:spPr>
-          <a:xfrm>
-            <a:off x="457200" y="3474720"/>
-            <a:ext cx="11247120" cy="1005840"/>
-          </a:xfrm>
-          <a:prstGeom prst="rect">
-            <a:avLst/>
-          </a:prstGeom>
-          <a:noFill/>
-        </p:spPr>
-        <p:txBody>
-          <a:bodyPr wrap="square">
-            <a:spAutoFit/>
-          </a:bodyPr>
-          <a:lstStyle/>
-          <a:p>
-            <a:pPr algn="l">
-              <a:defRPr sz="1900" b="1">
-                <a:solidFill>
-                  <a:srgbClr val="1B3A5C"/>
-                </a:solidFill>
-                <a:latin typeface="Calibri"/>
-              </a:defRPr>
-            </a:pPr>
-            <a:r>
-              <a:t>3. Curse of dimensionality</a:t>
-            </a:r>
-          </a:p>
-          <a:p>
-            <a:pPr algn="l">
-              <a:spcBef>
-                <a:spcPts val="600"/>
-              </a:spcBef>
-              <a:defRPr sz="1500" b="0">
-                <a:solidFill>
-                  <a:srgbClr val="404040"/>
-                </a:solidFill>
-                <a:latin typeface="Calibri"/>
-              </a:defRPr>
-            </a:pPr>
-            <a:r>
-              <a:t>~210 vetores com 19 features → MicroTEDAclus não converge. Poucos vetores de ataque (2-55) se perdem no ruído.</a:t>
-            </a:r>
-          </a:p>
-        </p:txBody>
-      </p:sp>
-      <p:sp>
-        <p:nvSpPr>
-          <p:cNvPr id="7" name="TextBox 6"/>
-          <p:cNvSpPr txBox="1"/>
-          <p:nvPr/>
-        </p:nvSpPr>
-        <p:spPr>
-          <a:xfrm>
-            <a:off x="457200" y="4526279"/>
-            <a:ext cx="11247120" cy="1005840"/>
-          </a:xfrm>
-          <a:prstGeom prst="rect">
-            <a:avLst/>
-          </a:prstGeom>
-          <a:noFill/>
-        </p:spPr>
-        <p:txBody>
-          <a:bodyPr wrap="square">
-            <a:spAutoFit/>
-          </a:bodyPr>
-          <a:lstStyle/>
-          <a:p>
-            <a:pPr algn="l">
-              <a:defRPr sz="1900" b="1">
-                <a:solidFill>
-                  <a:srgbClr val="1B3A5C"/>
-                </a:solidFill>
-                <a:latin typeface="Calibri"/>
-              </a:defRPr>
-            </a:pPr>
-            <a:r>
-              <a:t>4. Não existe config única ótima</a:t>
-            </a:r>
-          </a:p>
-          <a:p>
-            <a:pPr algn="l">
-              <a:spcBef>
-                <a:spcPts val="600"/>
-              </a:spcBef>
-              <a:defRPr sz="1500" b="0">
-                <a:solidFill>
-                  <a:srgbClr val="404040"/>
-                </a:solidFill>
-                <a:latin typeface="Calibri"/>
-              </a:defRPr>
-            </a:pPr>
-            <a:r>
-              <a:t>ICMP precisa de v2, Mirai/SYN funcionam melhor com v1. DDoS-TCP é indistinguível em qualquer configuração.</a:t>
-            </a:r>
-          </a:p>
-        </p:txBody>
-      </p:sp>
-      <p:sp>
-        <p:nvSpPr>
-          <p:cNvPr id="8" name="TextBox 7"/>
-          <p:cNvSpPr txBox="1"/>
-          <p:nvPr/>
-        </p:nvSpPr>
-        <p:spPr>
-          <a:xfrm>
-            <a:off x="457200" y="5577840"/>
-            <a:ext cx="11247120" cy="1005840"/>
-          </a:xfrm>
-          <a:prstGeom prst="rect">
-            <a:avLst/>
-          </a:prstGeom>
-          <a:noFill/>
-        </p:spPr>
-        <p:txBody>
-          <a:bodyPr wrap="square">
-            <a:spAutoFit/>
-          </a:bodyPr>
-          <a:lstStyle/>
-          <a:p>
-            <a:pPr algn="l">
-              <a:defRPr sz="1900" b="1">
-                <a:solidFill>
-                  <a:srgbClr val="1B3A5C"/>
-                </a:solidFill>
-                <a:latin typeface="Calibri"/>
-              </a:defRPr>
-            </a:pPr>
-            <a:r>
-              <a:t>5. Resultado positivo: Recon F1=43.7%</a:t>
-            </a:r>
-          </a:p>
-          <a:p>
-            <a:pPr algn="l">
-              <a:spcBef>
-                <a:spcPts val="600"/>
-              </a:spcBef>
-              <a:defRPr sz="1500" b="0">
-                <a:solidFill>
-                  <a:srgbClr val="404040"/>
-                </a:solidFill>
-                <a:latin typeface="Calibri"/>
-              </a:defRPr>
-            </a:pPr>
-            <a:r>
-              <a:t>Demonstra que o pipeline Kafka → MicroTEDAclus funciona para certos tipos de ataque. Comparável com IDS não-supervisionados da literatura.</a:t>
+              <a:t>Alternativa: r0=0.15 → Precision 56.7%, FPR apenas 4.2%, F1=42.0%</a:t>
             </a:r>
           </a:p>
         </p:txBody>
@@ -3716,6 +4476,423 @@
               </a:defRPr>
             </a:pPr>
             <a:r>
+              <a:t>6 Insights Principais</a:t>
+            </a:r>
+          </a:p>
+        </p:txBody>
+      </p:sp>
+      <p:sp>
+        <p:nvSpPr>
+          <p:cNvPr id="4" name="TextBox 3"/>
+          <p:cNvSpPr txBox="1"/>
+          <p:nvPr/>
+        </p:nvSpPr>
+        <p:spPr>
+          <a:xfrm>
+            <a:off x="457200" y="1371600"/>
+            <a:ext cx="11247120" cy="822960"/>
+          </a:xfrm>
+          <a:prstGeom prst="rect">
+            <a:avLst/>
+          </a:prstGeom>
+          <a:noFill/>
+        </p:spPr>
+        <p:txBody>
+          <a:bodyPr wrap="square">
+            <a:spAutoFit/>
+          </a:bodyPr>
+          <a:lstStyle/>
+          <a:p>
+            <a:pPr algn="l">
+              <a:defRPr sz="1800" b="1">
+                <a:solidFill>
+                  <a:srgbClr val="1B3A5C"/>
+                </a:solidFill>
+                <a:latin typeface="Calibri"/>
+              </a:defRPr>
+            </a:pPr>
+            <a:r>
+              <a:t>1. Detecção per-flow é fundamentalmente limitada</a:t>
+            </a:r>
+          </a:p>
+          <a:p>
+            <a:pPr algn="l">
+              <a:spcBef>
+                <a:spcPts val="600"/>
+              </a:spcBef>
+              <a:defRPr sz="1400" b="0">
+                <a:solidFill>
+                  <a:srgbClr val="404040"/>
+                </a:solidFill>
+                <a:latin typeface="Calibri"/>
+              </a:defRPr>
+            </a:pPr>
+            <a:r>
+              <a:t>Flows de ataque DDoS são estatisticamente indistinguíveis de flows benignos IoT. Mais features per-flow (17→32) não ajudam — o problema é estrutural.</a:t>
+            </a:r>
+          </a:p>
+        </p:txBody>
+      </p:sp>
+      <p:sp>
+        <p:nvSpPr>
+          <p:cNvPr id="5" name="TextBox 4"/>
+          <p:cNvSpPr txBox="1"/>
+          <p:nvPr/>
+        </p:nvSpPr>
+        <p:spPr>
+          <a:xfrm>
+            <a:off x="457200" y="2240280"/>
+            <a:ext cx="11247120" cy="822960"/>
+          </a:xfrm>
+          <a:prstGeom prst="rect">
+            <a:avLst/>
+          </a:prstGeom>
+          <a:noFill/>
+        </p:spPr>
+        <p:txBody>
+          <a:bodyPr wrap="square">
+            <a:spAutoFit/>
+          </a:bodyPr>
+          <a:lstStyle/>
+          <a:p>
+            <a:pPr algn="l">
+              <a:defRPr sz="1800" b="1">
+                <a:solidFill>
+                  <a:srgbClr val="1B3A5C"/>
+                </a:solidFill>
+                <a:latin typeface="Calibri"/>
+              </a:defRPr>
+            </a:pPr>
+            <a:r>
+              <a:t>2. Janelas temporais são a direção certa</a:t>
+            </a:r>
+          </a:p>
+          <a:p>
+            <a:pPr algn="l">
+              <a:spcBef>
+                <a:spcPts val="600"/>
+              </a:spcBef>
+              <a:defRPr sz="1400" b="0">
+                <a:solidFill>
+                  <a:srgbClr val="404040"/>
+                </a:solidFill>
+                <a:latin typeface="Calibri"/>
+              </a:defRPr>
+            </a:pPr>
+            <a:r>
+              <a:t>Mudam a pergunta de "este flow é anômalo?" para "este IP tem comportamento anômalo?". Melhorias de 10-20x no Recall.</a:t>
+            </a:r>
+          </a:p>
+        </p:txBody>
+      </p:sp>
+      <p:sp>
+        <p:nvSpPr>
+          <p:cNvPr id="6" name="TextBox 5"/>
+          <p:cNvSpPr txBox="1"/>
+          <p:nvPr/>
+        </p:nvSpPr>
+        <p:spPr>
+          <a:xfrm>
+            <a:off x="457200" y="3108960"/>
+            <a:ext cx="11247120" cy="822960"/>
+          </a:xfrm>
+          <a:prstGeom prst="rect">
+            <a:avLst/>
+          </a:prstGeom>
+          <a:noFill/>
+        </p:spPr>
+        <p:txBody>
+          <a:bodyPr wrap="square">
+            <a:spAutoFit/>
+          </a:bodyPr>
+          <a:lstStyle/>
+          <a:p>
+            <a:pPr algn="l">
+              <a:defRPr sz="1800" b="1">
+                <a:solidFill>
+                  <a:srgbClr val="1B3A5C"/>
+                </a:solidFill>
+                <a:latin typeface="Calibri"/>
+              </a:defRPr>
+            </a:pPr>
+            <a:r>
+              <a:t>3. Curse of dimensionality</a:t>
+            </a:r>
+          </a:p>
+          <a:p>
+            <a:pPr algn="l">
+              <a:spcBef>
+                <a:spcPts val="600"/>
+              </a:spcBef>
+              <a:defRPr sz="1400" b="0">
+                <a:solidFill>
+                  <a:srgbClr val="404040"/>
+                </a:solidFill>
+                <a:latin typeface="Calibri"/>
+              </a:defRPr>
+            </a:pPr>
+            <a:r>
+              <a:t>~210 vetores com 19 features — MicroTEDAclus não converge com poucos dados.</a:t>
+            </a:r>
+          </a:p>
+        </p:txBody>
+      </p:sp>
+      <p:sp>
+        <p:nvSpPr>
+          <p:cNvPr id="7" name="TextBox 6"/>
+          <p:cNvSpPr txBox="1"/>
+          <p:nvPr/>
+        </p:nvSpPr>
+        <p:spPr>
+          <a:xfrm>
+            <a:off x="457200" y="3977639"/>
+            <a:ext cx="11247120" cy="822960"/>
+          </a:xfrm>
+          <a:prstGeom prst="rect">
+            <a:avLst/>
+          </a:prstGeom>
+          <a:noFill/>
+        </p:spPr>
+        <p:txBody>
+          <a:bodyPr wrap="square">
+            <a:spAutoFit/>
+          </a:bodyPr>
+          <a:lstStyle/>
+          <a:p>
+            <a:pPr algn="l">
+              <a:defRPr sz="1800" b="1">
+                <a:solidFill>
+                  <a:srgbClr val="1B3A5C"/>
+                </a:solidFill>
+                <a:latin typeface="Calibri"/>
+              </a:defRPr>
+            </a:pPr>
+            <a:r>
+              <a:t>4. Não existe config única ótima</a:t>
+            </a:r>
+          </a:p>
+          <a:p>
+            <a:pPr algn="l">
+              <a:spcBef>
+                <a:spcPts val="600"/>
+              </a:spcBef>
+              <a:defRPr sz="1400" b="0">
+                <a:solidFill>
+                  <a:srgbClr val="404040"/>
+                </a:solidFill>
+                <a:latin typeface="Calibri"/>
+              </a:defRPr>
+            </a:pPr>
+            <a:r>
+              <a:t>ICMP precisa de v2, Mirai/SYN funcionam melhor com v1. DDoS-TCP é indistinguível em qualquer configuração.</a:t>
+            </a:r>
+          </a:p>
+        </p:txBody>
+      </p:sp>
+      <p:sp>
+        <p:nvSpPr>
+          <p:cNvPr id="8" name="TextBox 7"/>
+          <p:cNvSpPr txBox="1"/>
+          <p:nvPr/>
+        </p:nvSpPr>
+        <p:spPr>
+          <a:xfrm>
+            <a:off x="457200" y="4846320"/>
+            <a:ext cx="11247120" cy="822960"/>
+          </a:xfrm>
+          <a:prstGeom prst="rect">
+            <a:avLst/>
+          </a:prstGeom>
+          <a:noFill/>
+        </p:spPr>
+        <p:txBody>
+          <a:bodyPr wrap="square">
+            <a:spAutoFit/>
+          </a:bodyPr>
+          <a:lstStyle/>
+          <a:p>
+            <a:pPr algn="l">
+              <a:defRPr sz="1800" b="1">
+                <a:solidFill>
+                  <a:srgbClr val="1B3A5C"/>
+                </a:solidFill>
+                <a:latin typeface="Calibri"/>
+              </a:defRPr>
+            </a:pPr>
+            <a:r>
+              <a:t>5. Resultado positivo: Recon F1=43.7%</a:t>
+            </a:r>
+          </a:p>
+          <a:p>
+            <a:pPr algn="l">
+              <a:spcBef>
+                <a:spcPts val="600"/>
+              </a:spcBef>
+              <a:defRPr sz="1400" b="0">
+                <a:solidFill>
+                  <a:srgbClr val="404040"/>
+                </a:solidFill>
+                <a:latin typeface="Calibri"/>
+              </a:defRPr>
+            </a:pPr>
+            <a:r>
+              <a:t>Pipeline Kafka → MicroTEDAclus funciona para certos tipos de ataque.</a:t>
+            </a:r>
+          </a:p>
+        </p:txBody>
+      </p:sp>
+      <p:sp>
+        <p:nvSpPr>
+          <p:cNvPr id="9" name="TextBox 8"/>
+          <p:cNvSpPr txBox="1"/>
+          <p:nvPr/>
+        </p:nvSpPr>
+        <p:spPr>
+          <a:xfrm>
+            <a:off x="457200" y="5715000"/>
+            <a:ext cx="11247120" cy="822960"/>
+          </a:xfrm>
+          <a:prstGeom prst="rect">
+            <a:avLst/>
+          </a:prstGeom>
+          <a:noFill/>
+        </p:spPr>
+        <p:txBody>
+          <a:bodyPr wrap="square">
+            <a:spAutoFit/>
+          </a:bodyPr>
+          <a:lstStyle/>
+          <a:p>
+            <a:pPr algn="l">
+              <a:defRPr sz="1800" b="1">
+                <a:solidFill>
+                  <a:srgbClr val="1B3A5C"/>
+                </a:solidFill>
+                <a:latin typeface="Calibri"/>
+              </a:defRPr>
+            </a:pPr>
+            <a:r>
+              <a:t>6. Adaptação ao domínio é contribuição técnica (C04)</a:t>
+            </a:r>
+          </a:p>
+          <a:p>
+            <a:pPr algn="l">
+              <a:spcBef>
+                <a:spcPts val="600"/>
+              </a:spcBef>
+              <a:defRPr sz="1400" b="0">
+                <a:solidFill>
+                  <a:srgbClr val="404040"/>
+                </a:solidFill>
+                <a:latin typeface="Calibri"/>
+              </a:defRPr>
+            </a:pPr>
+            <a:r>
+              <a:t>Implementação original (Maia 2020) produz FPR de 42-75% — inutilizável. Adaptações próprias (Welford, update seletivo) reduzem FPR para 3-15%.</a:t>
+            </a:r>
+          </a:p>
+        </p:txBody>
+      </p:sp>
+    </p:spTree>
+  </p:cSld>
+  <p:clrMapOvr>
+    <a:masterClrMapping/>
+  </p:clrMapOvr>
+</p:sld>
+</file>
+
+<file path=ppt/slides/slide12.xml><?xml version="1.0" encoding="utf-8"?>
+<p:sld xmlns:a="http://schemas.openxmlformats.org/drawingml/2006/main" xmlns:p="http://schemas.openxmlformats.org/presentationml/2006/main" xmlns:r="http://schemas.openxmlformats.org/officeDocument/2006/relationships">
+  <p:cSld>
+    <p:bg>
+      <p:bgPr>
+        <a:solidFill>
+          <a:srgbClr val="FFFFFF"/>
+        </a:solidFill>
+        <a:effectLst/>
+      </p:bgPr>
+    </p:bg>
+    <p:spTree>
+      <p:nvGrpSpPr>
+        <p:cNvPr id="1" name=""/>
+        <p:cNvGrpSpPr/>
+        <p:nvPr/>
+      </p:nvGrpSpPr>
+      <p:grpSpPr/>
+      <p:sp>
+        <p:nvSpPr>
+          <p:cNvPr id="2" name="Rectangle 1"/>
+          <p:cNvSpPr/>
+          <p:nvPr/>
+        </p:nvSpPr>
+        <p:spPr>
+          <a:xfrm>
+            <a:off x="0" y="0"/>
+            <a:ext cx="12191695" cy="1097280"/>
+          </a:xfrm>
+          <a:prstGeom prst="rect">
+            <a:avLst/>
+          </a:prstGeom>
+          <a:solidFill>
+            <a:srgbClr val="1B3A5C"/>
+          </a:solidFill>
+          <a:ln>
+            <a:noFill/>
+          </a:ln>
+        </p:spPr>
+        <p:style>
+          <a:lnRef idx="1">
+            <a:schemeClr val="accent1"/>
+          </a:lnRef>
+          <a:fillRef idx="3">
+            <a:schemeClr val="accent1"/>
+          </a:fillRef>
+          <a:effectRef idx="2">
+            <a:schemeClr val="accent1"/>
+          </a:effectRef>
+          <a:fontRef idx="minor">
+            <a:schemeClr val="lt1"/>
+          </a:fontRef>
+        </p:style>
+        <p:txBody>
+          <a:bodyPr rtlCol="0" anchor="ctr"/>
+          <a:lstStyle/>
+          <a:p>
+            <a:pPr algn="ctr"/>
+          </a:p>
+        </p:txBody>
+      </p:sp>
+      <p:sp>
+        <p:nvSpPr>
+          <p:cNvPr id="3" name="TextBox 2"/>
+          <p:cNvSpPr txBox="1"/>
+          <p:nvPr/>
+        </p:nvSpPr>
+        <p:spPr>
+          <a:xfrm>
+            <a:off x="457200" y="137160"/>
+            <a:ext cx="10972800" cy="822960"/>
+          </a:xfrm>
+          <a:prstGeom prst="rect">
+            <a:avLst/>
+          </a:prstGeom>
+          <a:noFill/>
+        </p:spPr>
+        <p:txBody>
+          <a:bodyPr wrap="square">
+            <a:spAutoFit/>
+          </a:bodyPr>
+          <a:lstStyle/>
+          <a:p>
+            <a:pPr algn="l">
+              <a:defRPr sz="3200" b="1">
+                <a:solidFill>
+                  <a:srgbClr val="FFFFFF"/>
+                </a:solidFill>
+                <a:latin typeface="Calibri"/>
+              </a:defRPr>
+            </a:pPr>
+            <a:r>
               <a:t>Próximos Passos — 3 Opções</a:t>
             </a:r>
           </a:p>
@@ -4093,7 +5270,7 @@
               </a:defRPr>
             </a:pPr>
             <a:r>
-              <a:t>137 exps + ablation rigoroso</a:t>
+              <a:t>167 exps + ablation rigoroso</a:t>
             </a:r>
           </a:p>
           <a:p>
@@ -4376,7 +5553,7 @@
 </p:sld>
 </file>
 
-<file path=ppt/slides/slide12.xml><?xml version="1.0" encoding="utf-8"?>
+<file path=ppt/slides/slide13.xml><?xml version="1.0" encoding="utf-8"?>
 <p:sld xmlns:a="http://schemas.openxmlformats.org/drawingml/2006/main" xmlns:p="http://schemas.openxmlformats.org/presentationml/2006/main" xmlns:r="http://schemas.openxmlformats.org/officeDocument/2006/relationships">
   <p:cSld>
     <p:bg>
@@ -5876,7 +7053,7 @@
               </a:defRPr>
             </a:pPr>
             <a:r>
-              <a:t>Consolidado</a:t>
+              <a:t>Campaign-04</a:t>
             </a:r>
           </a:p>
           <a:p>
@@ -5892,7 +7069,7 @@
               </a:defRPr>
             </a:pPr>
             <a:r>
-              <a:t>Melhor resultado por ataque</a:t>
+              <a:t>Original vs Próprio — validação da implementação</a:t>
             </a:r>
           </a:p>
         </p:txBody>
@@ -5964,7 +7141,7 @@
               </a:defRPr>
             </a:pPr>
             <a:r>
-              <a:t>Insights</a:t>
+              <a:t>Consolidado + Insights</a:t>
             </a:r>
           </a:p>
           <a:p>
@@ -5980,7 +7157,7 @@
               </a:defRPr>
             </a:pPr>
             <a:r>
-              <a:t>5 pontos-chave</a:t>
+              <a:t>Melhor resultado por ataque + 6 pontos-chave</a:t>
             </a:r>
           </a:p>
         </p:txBody>
@@ -7023,7 +8200,7 @@
         </p:nvGraphicFramePr>
         <p:xfrm>
           <a:off x="457200" y="1371600"/>
-          <a:ext cx="11247120" cy="4114800"/>
+          <a:ext cx="11247120" cy="4389120"/>
         </p:xfrm>
         <a:graphic>
           <a:graphicData uri="http://schemas.openxmlformats.org/drawingml/2006/table">
@@ -7038,7 +8215,7 @@
                 <a:gridCol w="2249424"/>
                 <a:gridCol w="2249424"/>
               </a:tblGrid>
-              <a:tr h="685800">
+              <a:tr h="627017">
                 <a:tc>
                   <a:txBody>
                     <a:bodyPr/>
@@ -7160,7 +8337,7 @@
                   </a:tcPr>
                 </a:tc>
               </a:tr>
-              <a:tr h="685800">
+              <a:tr h="627017">
                 <a:tc>
                   <a:txBody>
                     <a:bodyPr/>
@@ -7266,7 +8443,7 @@
                   </a:tcPr>
                 </a:tc>
               </a:tr>
-              <a:tr h="685800">
+              <a:tr h="627017">
                 <a:tc>
                   <a:txBody>
                     <a:bodyPr/>
@@ -7372,7 +8549,7 @@
                   </a:tcPr>
                 </a:tc>
               </a:tr>
-              <a:tr h="685800">
+              <a:tr h="627017">
                 <a:tc>
                   <a:txBody>
                     <a:bodyPr/>
@@ -7478,7 +8655,7 @@
                   </a:tcPr>
                 </a:tc>
               </a:tr>
-              <a:tr h="685800">
+              <a:tr h="627017">
                 <a:tc>
                   <a:txBody>
                     <a:bodyPr/>
@@ -7580,7 +8757,7 @@
                   <a:tcPr anchor="ctr"/>
                 </a:tc>
               </a:tr>
-              <a:tr h="685800">
+              <a:tr h="627017">
                 <a:tc>
                   <a:txBody>
                     <a:bodyPr/>
@@ -7680,6 +8857,112 @@
                     </a:p>
                   </a:txBody>
                   <a:tcPr anchor="ctr"/>
+                </a:tc>
+              </a:tr>
+              <a:tr h="627018">
+                <a:tc>
+                  <a:txBody>
+                    <a:bodyPr/>
+                    <a:lstStyle/>
+                    <a:p>
+                      <a:pPr algn="ctr">
+                        <a:defRPr sz="1300" b="0">
+                          <a:solidFill>
+                            <a:srgbClr val="000000"/>
+                          </a:solidFill>
+                          <a:latin typeface="Calibri"/>
+                        </a:defRPr>
+                      </a:pPr>
+                      <a:r>
+                        <a:t>C04</a:t>
+                      </a:r>
+                    </a:p>
+                  </a:txBody>
+                  <a:tcPr anchor="ctr"/>
+                </a:tc>
+                <a:tc>
+                  <a:txBody>
+                    <a:bodyPr/>
+                    <a:lstStyle/>
+                    <a:p>
+                      <a:pPr algn="ctr">
+                        <a:defRPr sz="1300" b="0">
+                          <a:solidFill>
+                            <a:srgbClr val="000000"/>
+                          </a:solidFill>
+                          <a:latin typeface="Calibri"/>
+                        </a:defRPr>
+                      </a:pPr>
+                      <a:r>
+                        <a:t>Implementação</a:t>
+                      </a:r>
+                    </a:p>
+                  </a:txBody>
+                  <a:tcPr anchor="ctr"/>
+                </a:tc>
+                <a:tc>
+                  <a:txBody>
+                    <a:bodyPr/>
+                    <a:lstStyle/>
+                    <a:p>
+                      <a:pPr algn="ctr">
+                        <a:defRPr sz="1300" b="0">
+                          <a:solidFill>
+                            <a:srgbClr val="000000"/>
+                          </a:solidFill>
+                          <a:latin typeface="Calibri"/>
+                        </a:defRPr>
+                      </a:pPr>
+                      <a:r>
+                        <a:t>Própria vs Original (Maia)</a:t>
+                      </a:r>
+                    </a:p>
+                  </a:txBody>
+                  <a:tcPr anchor="ctr"/>
+                </a:tc>
+                <a:tc>
+                  <a:txBody>
+                    <a:bodyPr/>
+                    <a:lstStyle/>
+                    <a:p>
+                      <a:pPr algn="ctr">
+                        <a:defRPr sz="1300" b="0">
+                          <a:solidFill>
+                            <a:srgbClr val="000000"/>
+                          </a:solidFill>
+                          <a:latin typeface="Calibri"/>
+                        </a:defRPr>
+                      </a:pPr>
+                      <a:r>
+                        <a:t>Original FPR 42-75%</a:t>
+                      </a:r>
+                    </a:p>
+                  </a:txBody>
+                  <a:tcPr anchor="ctr"/>
+                </a:tc>
+                <a:tc>
+                  <a:txBody>
+                    <a:bodyPr/>
+                    <a:lstStyle/>
+                    <a:p>
+                      <a:pPr algn="ctr">
+                        <a:defRPr sz="1300" b="0">
+                          <a:solidFill>
+                            <a:srgbClr val="000000"/>
+                          </a:solidFill>
+                          <a:latin typeface="Calibri"/>
+                        </a:defRPr>
+                      </a:pPr>
+                      <a:r>
+                        <a:t>Própria superior</a:t>
+                      </a:r>
+                    </a:p>
+                  </a:txBody>
+                  <a:tcPr anchor="ctr">
+                    <a:solidFill>
+                      <a:srgbClr val="E8F5E9"/>
+                    </a:solidFill>
+                  </a:tcPr>
                 </a:tc>
               </a:tr>
             </a:tbl>
@@ -9928,972 +11211,45 @@
               </a:defRPr>
             </a:pPr>
             <a:r>
-              <a:t>Consolidado — Melhor Resultado por Ataque</a:t>
-            </a:r>
-          </a:p>
-        </p:txBody>
-      </p:sp>
-      <p:graphicFrame>
-        <p:nvGraphicFramePr>
-          <p:cNvPr id="4" name="Table 3"/>
-          <p:cNvGraphicFramePr>
-            <a:graphicFrameLocks noGrp="1"/>
-          </p:cNvGraphicFramePr>
+              <a:t>C04 — Original (Maia 2020) vs Implementação Própria (30 runs)</a:t>
+            </a:r>
+          </a:p>
+        </p:txBody>
+      </p:sp>
+      <p:pic>
+        <p:nvPicPr>
+          <p:cNvPr id="4" name="Picture 3" descr="06_campaign04_dashboard.png"/>
+          <p:cNvPicPr>
+            <a:picLocks noChangeAspect="1"/>
+          </p:cNvPicPr>
           <p:nvPr/>
-        </p:nvGraphicFramePr>
-        <p:xfrm>
-          <a:off x="457200" y="1371600"/>
-          <a:ext cx="11247120" cy="3200400"/>
-        </p:xfrm>
-        <a:graphic>
-          <a:graphicData uri="http://schemas.openxmlformats.org/drawingml/2006/table">
-            <a:tbl>
-              <a:tblPr firstRow="1" bandRow="1">
-                <a:tableStyleId>{5C22544A-7EE6-4342-B048-85BDC9FD1C3A}</a:tableStyleId>
-              </a:tblPr>
-              <a:tblGrid>
-                <a:gridCol w="1874520"/>
-                <a:gridCol w="1874520"/>
-                <a:gridCol w="1874520"/>
-                <a:gridCol w="1874520"/>
-                <a:gridCol w="1874520"/>
-                <a:gridCol w="1874520"/>
-              </a:tblGrid>
-              <a:tr h="457200">
-                <a:tc>
-                  <a:txBody>
-                    <a:bodyPr/>
-                    <a:lstStyle/>
-                    <a:p>
-                      <a:pPr>
-                        <a:defRPr b="1" sz="1400">
-                          <a:solidFill>
-                            <a:srgbClr val="FFFFFF"/>
-                          </a:solidFill>
-                          <a:latin typeface="Calibri"/>
-                        </a:defRPr>
-                      </a:pPr>
-                      <a:r>
-                        <a:t>Ataque</a:t>
-                      </a:r>
-                    </a:p>
-                  </a:txBody>
-                  <a:tcPr>
-                    <a:solidFill>
-                      <a:srgbClr val="1B3A5C"/>
-                    </a:solidFill>
-                  </a:tcPr>
-                </a:tc>
-                <a:tc>
-                  <a:txBody>
-                    <a:bodyPr/>
-                    <a:lstStyle/>
-                    <a:p>
-                      <a:pPr>
-                        <a:defRPr b="1" sz="1400">
-                          <a:solidFill>
-                            <a:srgbClr val="FFFFFF"/>
-                          </a:solidFill>
-                          <a:latin typeface="Calibri"/>
-                        </a:defRPr>
-                      </a:pPr>
-                      <a:r>
-                        <a:t>Campanha</a:t>
-                      </a:r>
-                    </a:p>
-                  </a:txBody>
-                  <a:tcPr>
-                    <a:solidFill>
-                      <a:srgbClr val="1B3A5C"/>
-                    </a:solidFill>
-                  </a:tcPr>
-                </a:tc>
-                <a:tc>
-                  <a:txBody>
-                    <a:bodyPr/>
-                    <a:lstStyle/>
-                    <a:p>
-                      <a:pPr>
-                        <a:defRPr b="1" sz="1400">
-                          <a:solidFill>
-                            <a:srgbClr val="FFFFFF"/>
-                          </a:solidFill>
-                          <a:latin typeface="Calibri"/>
-                        </a:defRPr>
-                      </a:pPr>
-                      <a:r>
-                        <a:t>Config</a:t>
-                      </a:r>
-                    </a:p>
-                  </a:txBody>
-                  <a:tcPr>
-                    <a:solidFill>
-                      <a:srgbClr val="1B3A5C"/>
-                    </a:solidFill>
-                  </a:tcPr>
-                </a:tc>
-                <a:tc>
-                  <a:txBody>
-                    <a:bodyPr/>
-                    <a:lstStyle/>
-                    <a:p>
-                      <a:pPr>
-                        <a:defRPr b="1" sz="1400">
-                          <a:solidFill>
-                            <a:srgbClr val="FFFFFF"/>
-                          </a:solidFill>
-                          <a:latin typeface="Calibri"/>
-                        </a:defRPr>
-                      </a:pPr>
-                      <a:r>
-                        <a:t>Recall</a:t>
-                      </a:r>
-                    </a:p>
-                  </a:txBody>
-                  <a:tcPr>
-                    <a:solidFill>
-                      <a:srgbClr val="1B3A5C"/>
-                    </a:solidFill>
-                  </a:tcPr>
-                </a:tc>
-                <a:tc>
-                  <a:txBody>
-                    <a:bodyPr/>
-                    <a:lstStyle/>
-                    <a:p>
-                      <a:pPr>
-                        <a:defRPr b="1" sz="1400">
-                          <a:solidFill>
-                            <a:srgbClr val="FFFFFF"/>
-                          </a:solidFill>
-                          <a:latin typeface="Calibri"/>
-                        </a:defRPr>
-                      </a:pPr>
-                      <a:r>
-                        <a:t>F1</a:t>
-                      </a:r>
-                    </a:p>
-                  </a:txBody>
-                  <a:tcPr>
-                    <a:solidFill>
-                      <a:srgbClr val="1B3A5C"/>
-                    </a:solidFill>
-                  </a:tcPr>
-                </a:tc>
-                <a:tc>
-                  <a:txBody>
-                    <a:bodyPr/>
-                    <a:lstStyle/>
-                    <a:p>
-                      <a:pPr>
-                        <a:defRPr b="1" sz="1400">
-                          <a:solidFill>
-                            <a:srgbClr val="FFFFFF"/>
-                          </a:solidFill>
-                          <a:latin typeface="Calibri"/>
-                        </a:defRPr>
-                      </a:pPr>
-                      <a:r>
-                        <a:t>FPR</a:t>
-                      </a:r>
-                    </a:p>
-                  </a:txBody>
-                  <a:tcPr>
-                    <a:solidFill>
-                      <a:srgbClr val="1B3A5C"/>
-                    </a:solidFill>
-                  </a:tcPr>
-                </a:tc>
-              </a:tr>
-              <a:tr h="457200">
-                <a:tc>
-                  <a:txBody>
-                    <a:bodyPr/>
-                    <a:lstStyle/>
-                    <a:p>
-                      <a:pPr algn="ctr">
-                        <a:defRPr sz="1300" b="0">
-                          <a:solidFill>
-                            <a:srgbClr val="000000"/>
-                          </a:solidFill>
-                          <a:latin typeface="Calibri"/>
-                        </a:defRPr>
-                      </a:pPr>
-                      <a:r>
-                        <a:t>DDoS-ICMP</a:t>
-                      </a:r>
-                    </a:p>
-                  </a:txBody>
-                  <a:tcPr anchor="ctr"/>
-                </a:tc>
-                <a:tc>
-                  <a:txBody>
-                    <a:bodyPr/>
-                    <a:lstStyle/>
-                    <a:p>
-                      <a:pPr algn="ctr">
-                        <a:defRPr sz="1300" b="0">
-                          <a:solidFill>
-                            <a:srgbClr val="000000"/>
-                          </a:solidFill>
-                          <a:latin typeface="Calibri"/>
-                        </a:defRPr>
-                      </a:pPr>
-                      <a:r>
-                        <a:t>C03-S4</a:t>
-                      </a:r>
-                    </a:p>
-                  </a:txBody>
-                  <a:tcPr anchor="ctr"/>
-                </a:tc>
-                <a:tc>
-                  <a:txBody>
-                    <a:bodyPr/>
-                    <a:lstStyle/>
-                    <a:p>
-                      <a:pPr algn="ctr">
-                        <a:defRPr sz="1300" b="0">
-                          <a:solidFill>
-                            <a:srgbClr val="000000"/>
-                          </a:solidFill>
-                          <a:latin typeface="Calibri"/>
-                        </a:defRPr>
-                      </a:pPr>
-                      <a:r>
-                        <a:t>v2 / w10s / r0=0.10</a:t>
-                      </a:r>
-                    </a:p>
-                  </a:txBody>
-                  <a:tcPr anchor="ctr"/>
-                </a:tc>
-                <a:tc>
-                  <a:txBody>
-                    <a:bodyPr/>
-                    <a:lstStyle/>
-                    <a:p>
-                      <a:pPr algn="ctr">
-                        <a:defRPr sz="1300" b="0">
-                          <a:solidFill>
-                            <a:srgbClr val="000000"/>
-                          </a:solidFill>
-                          <a:latin typeface="Calibri"/>
-                        </a:defRPr>
-                      </a:pPr>
-                      <a:r>
-                        <a:t>50.0%</a:t>
-                      </a:r>
-                    </a:p>
-                  </a:txBody>
-                  <a:tcPr anchor="ctr"/>
-                </a:tc>
-                <a:tc>
-                  <a:txBody>
-                    <a:bodyPr/>
-                    <a:lstStyle/>
-                    <a:p>
-                      <a:pPr algn="ctr">
-                        <a:defRPr sz="1300" b="0">
-                          <a:solidFill>
-                            <a:srgbClr val="000000"/>
-                          </a:solidFill>
-                          <a:latin typeface="Calibri"/>
-                        </a:defRPr>
-                      </a:pPr>
-                      <a:r>
-                        <a:t>5.6%</a:t>
-                      </a:r>
-                    </a:p>
-                  </a:txBody>
-                  <a:tcPr anchor="ctr"/>
-                </a:tc>
-                <a:tc>
-                  <a:txBody>
-                    <a:bodyPr/>
-                    <a:lstStyle/>
-                    <a:p>
-                      <a:pPr algn="ctr">
-                        <a:defRPr sz="1300" b="0">
-                          <a:solidFill>
-                            <a:srgbClr val="000000"/>
-                          </a:solidFill>
-                          <a:latin typeface="Calibri"/>
-                        </a:defRPr>
-                      </a:pPr>
-                      <a:r>
-                        <a:t>15.7%</a:t>
-                      </a:r>
-                    </a:p>
-                  </a:txBody>
-                  <a:tcPr anchor="ctr"/>
-                </a:tc>
-              </a:tr>
-              <a:tr h="457200">
-                <a:tc>
-                  <a:txBody>
-                    <a:bodyPr/>
-                    <a:lstStyle/>
-                    <a:p>
-                      <a:pPr algn="ctr">
-                        <a:defRPr sz="1300" b="0">
-                          <a:solidFill>
-                            <a:srgbClr val="000000"/>
-                          </a:solidFill>
-                          <a:latin typeface="Calibri"/>
-                        </a:defRPr>
-                      </a:pPr>
-                      <a:r>
-                        <a:t>DDoS-SYN</a:t>
-                      </a:r>
-                    </a:p>
-                  </a:txBody>
-                  <a:tcPr anchor="ctr"/>
-                </a:tc>
-                <a:tc>
-                  <a:txBody>
-                    <a:bodyPr/>
-                    <a:lstStyle/>
-                    <a:p>
-                      <a:pPr algn="ctr">
-                        <a:defRPr sz="1300" b="0">
-                          <a:solidFill>
-                            <a:srgbClr val="000000"/>
-                          </a:solidFill>
-                          <a:latin typeface="Calibri"/>
-                        </a:defRPr>
-                      </a:pPr>
-                      <a:r>
-                        <a:t>C03-S4</a:t>
-                      </a:r>
-                    </a:p>
-                  </a:txBody>
-                  <a:tcPr anchor="ctr"/>
-                </a:tc>
-                <a:tc>
-                  <a:txBody>
-                    <a:bodyPr/>
-                    <a:lstStyle/>
-                    <a:p>
-                      <a:pPr algn="ctr">
-                        <a:defRPr sz="1300" b="0">
-                          <a:solidFill>
-                            <a:srgbClr val="000000"/>
-                          </a:solidFill>
-                          <a:latin typeface="Calibri"/>
-                        </a:defRPr>
-                      </a:pPr>
-                      <a:r>
-                        <a:t>v2 / w30s / r0=0.05</a:t>
-                      </a:r>
-                    </a:p>
-                  </a:txBody>
-                  <a:tcPr anchor="ctr"/>
-                </a:tc>
-                <a:tc>
-                  <a:txBody>
-                    <a:bodyPr/>
-                    <a:lstStyle/>
-                    <a:p>
-                      <a:pPr algn="ctr">
-                        <a:defRPr sz="1300" b="0">
-                          <a:solidFill>
-                            <a:srgbClr val="000000"/>
-                          </a:solidFill>
-                          <a:latin typeface="Calibri"/>
-                        </a:defRPr>
-                      </a:pPr>
-                      <a:r>
-                        <a:t>61.5%</a:t>
-                      </a:r>
-                    </a:p>
-                  </a:txBody>
-                  <a:tcPr anchor="ctr"/>
-                </a:tc>
-                <a:tc>
-                  <a:txBody>
-                    <a:bodyPr/>
-                    <a:lstStyle/>
-                    <a:p>
-                      <a:pPr algn="ctr">
-                        <a:defRPr sz="1300" b="0">
-                          <a:solidFill>
-                            <a:srgbClr val="000000"/>
-                          </a:solidFill>
-                          <a:latin typeface="Calibri"/>
-                        </a:defRPr>
-                      </a:pPr>
-                      <a:r>
-                        <a:t>21.6%</a:t>
-                      </a:r>
-                    </a:p>
-                  </a:txBody>
-                  <a:tcPr anchor="ctr"/>
-                </a:tc>
-                <a:tc>
-                  <a:txBody>
-                    <a:bodyPr/>
-                    <a:lstStyle/>
-                    <a:p>
-                      <a:pPr algn="ctr">
-                        <a:defRPr sz="1300" b="0">
-                          <a:solidFill>
-                            <a:srgbClr val="000000"/>
-                          </a:solidFill>
-                          <a:latin typeface="Calibri"/>
-                        </a:defRPr>
-                      </a:pPr>
-                      <a:r>
-                        <a:t>36.1%</a:t>
-                      </a:r>
-                    </a:p>
-                  </a:txBody>
-                  <a:tcPr anchor="ctr"/>
-                </a:tc>
-              </a:tr>
-              <a:tr h="457200">
-                <a:tc>
-                  <a:txBody>
-                    <a:bodyPr/>
-                    <a:lstStyle/>
-                    <a:p>
-                      <a:pPr algn="ctr">
-                        <a:defRPr sz="1300" b="0">
-                          <a:solidFill>
-                            <a:srgbClr val="000000"/>
-                          </a:solidFill>
-                          <a:latin typeface="Calibri"/>
-                        </a:defRPr>
-                      </a:pPr>
-                      <a:r>
-                        <a:t>DDoS-TCP</a:t>
-                      </a:r>
-                    </a:p>
-                  </a:txBody>
-                  <a:tcPr anchor="ctr"/>
-                </a:tc>
-                <a:tc>
-                  <a:txBody>
-                    <a:bodyPr/>
-                    <a:lstStyle/>
-                    <a:p>
-                      <a:pPr algn="ctr">
-                        <a:defRPr sz="1300" b="0">
-                          <a:solidFill>
-                            <a:srgbClr val="000000"/>
-                          </a:solidFill>
-                          <a:latin typeface="Calibri"/>
-                        </a:defRPr>
-                      </a:pPr>
-                      <a:r>
-                        <a:t>—</a:t>
-                      </a:r>
-                    </a:p>
-                  </a:txBody>
-                  <a:tcPr anchor="ctr"/>
-                </a:tc>
-                <a:tc>
-                  <a:txBody>
-                    <a:bodyPr/>
-                    <a:lstStyle/>
-                    <a:p>
-                      <a:pPr algn="ctr">
-                        <a:defRPr sz="1300" b="0">
-                          <a:solidFill>
-                            <a:srgbClr val="E74C3C"/>
-                          </a:solidFill>
-                          <a:latin typeface="Calibri"/>
-                        </a:defRPr>
-                      </a:pPr>
-                      <a:r>
-                        <a:t>Indetectável</a:t>
-                      </a:r>
-                    </a:p>
-                  </a:txBody>
-                  <a:tcPr anchor="ctr"/>
-                </a:tc>
-                <a:tc>
-                  <a:txBody>
-                    <a:bodyPr/>
-                    <a:lstStyle/>
-                    <a:p>
-                      <a:pPr algn="ctr">
-                        <a:defRPr sz="1300" b="0">
-                          <a:solidFill>
-                            <a:srgbClr val="E74C3C"/>
-                          </a:solidFill>
-                          <a:latin typeface="Calibri"/>
-                        </a:defRPr>
-                      </a:pPr>
-                      <a:r>
-                        <a:t>0.0%</a:t>
-                      </a:r>
-                    </a:p>
-                  </a:txBody>
-                  <a:tcPr anchor="ctr"/>
-                </a:tc>
-                <a:tc>
-                  <a:txBody>
-                    <a:bodyPr/>
-                    <a:lstStyle/>
-                    <a:p>
-                      <a:pPr algn="ctr">
-                        <a:defRPr sz="1300" b="0">
-                          <a:solidFill>
-                            <a:srgbClr val="E74C3C"/>
-                          </a:solidFill>
-                          <a:latin typeface="Calibri"/>
-                        </a:defRPr>
-                      </a:pPr>
-                      <a:r>
-                        <a:t>0.0%</a:t>
-                      </a:r>
-                    </a:p>
-                  </a:txBody>
-                  <a:tcPr anchor="ctr"/>
-                </a:tc>
-                <a:tc>
-                  <a:txBody>
-                    <a:bodyPr/>
-                    <a:lstStyle/>
-                    <a:p>
-                      <a:pPr algn="ctr">
-                        <a:defRPr sz="1300" b="0">
-                          <a:solidFill>
-                            <a:srgbClr val="000000"/>
-                          </a:solidFill>
-                          <a:latin typeface="Calibri"/>
-                        </a:defRPr>
-                      </a:pPr>
-                      <a:r>
-                        <a:t>—</a:t>
-                      </a:r>
-                    </a:p>
-                  </a:txBody>
-                  <a:tcPr anchor="ctr"/>
-                </a:tc>
-              </a:tr>
-              <a:tr h="457200">
-                <a:tc>
-                  <a:txBody>
-                    <a:bodyPr/>
-                    <a:lstStyle/>
-                    <a:p>
-                      <a:pPr algn="ctr">
-                        <a:defRPr sz="1300" b="0">
-                          <a:solidFill>
-                            <a:srgbClr val="000000"/>
-                          </a:solidFill>
-                          <a:latin typeface="Calibri"/>
-                        </a:defRPr>
-                      </a:pPr>
-                      <a:r>
-                        <a:t>Mirai</a:t>
-                      </a:r>
-                    </a:p>
-                  </a:txBody>
-                  <a:tcPr anchor="ctr"/>
-                </a:tc>
-                <a:tc>
-                  <a:txBody>
-                    <a:bodyPr/>
-                    <a:lstStyle/>
-                    <a:p>
-                      <a:pPr algn="ctr">
-                        <a:defRPr sz="1300" b="0">
-                          <a:solidFill>
-                            <a:srgbClr val="000000"/>
-                          </a:solidFill>
-                          <a:latin typeface="Calibri"/>
-                        </a:defRPr>
-                      </a:pPr>
-                      <a:r>
-                        <a:t>C03-S4</a:t>
-                      </a:r>
-                    </a:p>
-                  </a:txBody>
-                  <a:tcPr anchor="ctr"/>
-                </a:tc>
-                <a:tc>
-                  <a:txBody>
-                    <a:bodyPr/>
-                    <a:lstStyle/>
-                    <a:p>
-                      <a:pPr algn="ctr">
-                        <a:defRPr sz="1300" b="0">
-                          <a:solidFill>
-                            <a:srgbClr val="000000"/>
-                          </a:solidFill>
-                          <a:latin typeface="Calibri"/>
-                        </a:defRPr>
-                      </a:pPr>
-                      <a:r>
-                        <a:t>v1 / w10s / r0=0.10</a:t>
-                      </a:r>
-                    </a:p>
-                  </a:txBody>
-                  <a:tcPr anchor="ctr"/>
-                </a:tc>
-                <a:tc>
-                  <a:txBody>
-                    <a:bodyPr/>
-                    <a:lstStyle/>
-                    <a:p>
-                      <a:pPr algn="ctr">
-                        <a:defRPr sz="1300" b="0">
-                          <a:solidFill>
-                            <a:srgbClr val="000000"/>
-                          </a:solidFill>
-                          <a:latin typeface="Calibri"/>
-                        </a:defRPr>
-                      </a:pPr>
-                      <a:r>
-                        <a:t>46.2%</a:t>
-                      </a:r>
-                    </a:p>
-                  </a:txBody>
-                  <a:tcPr anchor="ctr"/>
-                </a:tc>
-                <a:tc>
-                  <a:txBody>
-                    <a:bodyPr/>
-                    <a:lstStyle/>
-                    <a:p>
-                      <a:pPr algn="ctr">
-                        <a:defRPr sz="1300" b="0">
-                          <a:solidFill>
-                            <a:srgbClr val="000000"/>
-                          </a:solidFill>
-                          <a:latin typeface="Calibri"/>
-                        </a:defRPr>
-                      </a:pPr>
-                      <a:r>
-                        <a:t>23.1%</a:t>
-                      </a:r>
-                    </a:p>
-                  </a:txBody>
-                  <a:tcPr anchor="ctr"/>
-                </a:tc>
-                <a:tc>
-                  <a:txBody>
-                    <a:bodyPr/>
-                    <a:lstStyle/>
-                    <a:p>
-                      <a:pPr algn="ctr">
-                        <a:defRPr sz="1300" b="0">
-                          <a:solidFill>
-                            <a:srgbClr val="000000"/>
-                          </a:solidFill>
-                          <a:latin typeface="Calibri"/>
-                        </a:defRPr>
-                      </a:pPr>
-                      <a:r>
-                        <a:t>15.5%</a:t>
-                      </a:r>
-                    </a:p>
-                  </a:txBody>
-                  <a:tcPr anchor="ctr"/>
-                </a:tc>
-              </a:tr>
-              <a:tr h="457200">
-                <a:tc>
-                  <a:txBody>
-                    <a:bodyPr/>
-                    <a:lstStyle/>
-                    <a:p>
-                      <a:pPr algn="ctr">
-                        <a:defRPr sz="1300" b="1">
-                          <a:solidFill>
-                            <a:srgbClr val="000000"/>
-                          </a:solidFill>
-                          <a:latin typeface="Calibri"/>
-                        </a:defRPr>
-                      </a:pPr>
-                      <a:r>
-                        <a:t>Recon</a:t>
-                      </a:r>
-                    </a:p>
-                  </a:txBody>
-                  <a:tcPr anchor="ctr"/>
-                </a:tc>
-                <a:tc>
-                  <a:txBody>
-                    <a:bodyPr/>
-                    <a:lstStyle/>
-                    <a:p>
-                      <a:pPr algn="ctr">
-                        <a:defRPr sz="1300" b="1">
-                          <a:solidFill>
-                            <a:srgbClr val="000000"/>
-                          </a:solidFill>
-                          <a:latin typeface="Calibri"/>
-                        </a:defRPr>
-                      </a:pPr>
-                      <a:r>
-                        <a:t>C03-S4</a:t>
-                      </a:r>
-                    </a:p>
-                  </a:txBody>
-                  <a:tcPr anchor="ctr"/>
-                </a:tc>
-                <a:tc>
-                  <a:txBody>
-                    <a:bodyPr/>
-                    <a:lstStyle/>
-                    <a:p>
-                      <a:pPr algn="ctr">
-                        <a:defRPr sz="1300" b="1">
-                          <a:solidFill>
-                            <a:srgbClr val="000000"/>
-                          </a:solidFill>
-                          <a:latin typeface="Calibri"/>
-                        </a:defRPr>
-                      </a:pPr>
-                      <a:r>
-                        <a:t>v2 / w10s / r0=0.05</a:t>
-                      </a:r>
-                    </a:p>
-                  </a:txBody>
-                  <a:tcPr anchor="ctr"/>
-                </a:tc>
-                <a:tc>
-                  <a:txBody>
-                    <a:bodyPr/>
-                    <a:lstStyle/>
-                    <a:p>
-                      <a:pPr algn="ctr">
-                        <a:defRPr sz="1300" b="1">
-                          <a:solidFill>
-                            <a:srgbClr val="000000"/>
-                          </a:solidFill>
-                          <a:latin typeface="Calibri"/>
-                        </a:defRPr>
-                      </a:pPr>
-                      <a:r>
-                        <a:t>49.1%</a:t>
-                      </a:r>
-                    </a:p>
-                  </a:txBody>
-                  <a:tcPr anchor="ctr"/>
-                </a:tc>
-                <a:tc>
-                  <a:txBody>
-                    <a:bodyPr/>
-                    <a:lstStyle/>
-                    <a:p>
-                      <a:pPr algn="ctr">
-                        <a:defRPr sz="1300" b="1">
-                          <a:solidFill>
-                            <a:srgbClr val="27AE60"/>
-                          </a:solidFill>
-                          <a:latin typeface="Calibri"/>
-                        </a:defRPr>
-                      </a:pPr>
-                      <a:r>
-                        <a:t>43.7%</a:t>
-                      </a:r>
-                    </a:p>
-                  </a:txBody>
-                  <a:tcPr anchor="ctr"/>
-                </a:tc>
-                <a:tc>
-                  <a:txBody>
-                    <a:bodyPr/>
-                    <a:lstStyle/>
-                    <a:p>
-                      <a:pPr algn="ctr">
-                        <a:defRPr sz="1300" b="1">
-                          <a:solidFill>
-                            <a:srgbClr val="000000"/>
-                          </a:solidFill>
-                          <a:latin typeface="Calibri"/>
-                        </a:defRPr>
-                      </a:pPr>
-                      <a:r>
-                        <a:t>12.9%</a:t>
-                      </a:r>
-                    </a:p>
-                  </a:txBody>
-                  <a:tcPr anchor="ctr"/>
-                </a:tc>
-              </a:tr>
-              <a:tr h="457200">
-                <a:tc>
-                  <a:txBody>
-                    <a:bodyPr/>
-                    <a:lstStyle/>
-                    <a:p>
-                      <a:pPr algn="ctr">
-                        <a:defRPr sz="1300" b="0">
-                          <a:solidFill>
-                            <a:srgbClr val="000000"/>
-                          </a:solidFill>
-                          <a:latin typeface="Calibri"/>
-                        </a:defRPr>
-                      </a:pPr>
-                      <a:r>
-                        <a:t>Benigno (FPR)</a:t>
-                      </a:r>
-                    </a:p>
-                  </a:txBody>
-                  <a:tcPr anchor="ctr"/>
-                </a:tc>
-                <a:tc>
-                  <a:txBody>
-                    <a:bodyPr/>
-                    <a:lstStyle/>
-                    <a:p>
-                      <a:pPr algn="ctr">
-                        <a:defRPr sz="1300" b="0">
-                          <a:solidFill>
-                            <a:srgbClr val="000000"/>
-                          </a:solidFill>
-                          <a:latin typeface="Calibri"/>
-                        </a:defRPr>
-                      </a:pPr>
-                      <a:r>
-                        <a:t>C02-S1</a:t>
-                      </a:r>
-                    </a:p>
-                  </a:txBody>
-                  <a:tcPr anchor="ctr"/>
-                </a:tc>
-                <a:tc>
-                  <a:txBody>
-                    <a:bodyPr/>
-                    <a:lstStyle/>
-                    <a:p>
-                      <a:pPr algn="ctr">
-                        <a:defRPr sz="1300" b="0">
-                          <a:solidFill>
-                            <a:srgbClr val="000000"/>
-                          </a:solidFill>
-                          <a:latin typeface="Calibri"/>
-                        </a:defRPr>
-                      </a:pPr>
-                      <a:r>
-                        <a:t>flow-level / r0=0.10</a:t>
-                      </a:r>
-                    </a:p>
-                  </a:txBody>
-                  <a:tcPr anchor="ctr"/>
-                </a:tc>
-                <a:tc>
-                  <a:txBody>
-                    <a:bodyPr/>
-                    <a:lstStyle/>
-                    <a:p>
-                      <a:pPr algn="ctr">
-                        <a:defRPr sz="1300" b="0">
-                          <a:solidFill>
-                            <a:srgbClr val="000000"/>
-                          </a:solidFill>
-                          <a:latin typeface="Calibri"/>
-                        </a:defRPr>
-                      </a:pPr>
-                      <a:r>
-                        <a:t>—</a:t>
-                      </a:r>
-                    </a:p>
-                  </a:txBody>
-                  <a:tcPr anchor="ctr"/>
-                </a:tc>
-                <a:tc>
-                  <a:txBody>
-                    <a:bodyPr/>
-                    <a:lstStyle/>
-                    <a:p>
-                      <a:pPr algn="ctr">
-                        <a:defRPr sz="1300" b="0">
-                          <a:solidFill>
-                            <a:srgbClr val="000000"/>
-                          </a:solidFill>
-                          <a:latin typeface="Calibri"/>
-                        </a:defRPr>
-                      </a:pPr>
-                      <a:r>
-                        <a:t>—</a:t>
-                      </a:r>
-                    </a:p>
-                  </a:txBody>
-                  <a:tcPr anchor="ctr"/>
-                </a:tc>
-                <a:tc>
-                  <a:txBody>
-                    <a:bodyPr/>
-                    <a:lstStyle/>
-                    <a:p>
-                      <a:pPr algn="ctr">
-                        <a:defRPr sz="1300" b="0">
-                          <a:solidFill>
-                            <a:srgbClr val="000000"/>
-                          </a:solidFill>
-                          <a:latin typeface="Calibri"/>
-                        </a:defRPr>
-                      </a:pPr>
-                      <a:r>
-                        <a:t>3.5%</a:t>
-                      </a:r>
-                    </a:p>
-                  </a:txBody>
-                  <a:tcPr anchor="ctr"/>
-                </a:tc>
-              </a:tr>
-            </a:tbl>
-          </a:graphicData>
-        </a:graphic>
-      </p:graphicFrame>
-      <p:sp>
-        <p:nvSpPr>
-          <p:cNvPr id="5" name="Rounded Rectangle 4"/>
-          <p:cNvSpPr/>
-          <p:nvPr/>
-        </p:nvSpPr>
+        </p:nvPicPr>
+        <p:blipFill>
+          <a:blip r:embed="rId2"/>
+          <a:stretch>
+            <a:fillRect/>
+          </a:stretch>
+        </p:blipFill>
         <p:spPr>
           <a:xfrm>
-            <a:off x="457200" y="4846320"/>
-            <a:ext cx="11247120" cy="1645920"/>
+            <a:off x="182880" y="1188720"/>
+            <a:ext cx="7772400" cy="5486400"/>
           </a:xfrm>
-          <a:prstGeom prst="roundRect">
+          <a:prstGeom prst="rect">
             <a:avLst/>
           </a:prstGeom>
-          <a:solidFill>
-            <a:srgbClr val="E8F5E9"/>
-          </a:solidFill>
-          <a:ln>
-            <a:noFill/>
-          </a:ln>
         </p:spPr>
-        <p:style>
-          <a:lnRef idx="1">
-            <a:schemeClr val="accent1"/>
-          </a:lnRef>
-          <a:fillRef idx="3">
-            <a:schemeClr val="accent1"/>
-          </a:fillRef>
-          <a:effectRef idx="2">
-            <a:schemeClr val="accent1"/>
-          </a:effectRef>
-          <a:fontRef idx="minor">
-            <a:schemeClr val="lt1"/>
-          </a:fontRef>
-        </p:style>
-        <p:txBody>
-          <a:bodyPr rtlCol="0" anchor="ctr"/>
-          <a:lstStyle/>
-          <a:p>
-            <a:pPr algn="ctr"/>
-          </a:p>
-        </p:txBody>
-      </p:sp>
-      <p:sp>
-        <p:nvSpPr>
-          <p:cNvPr id="6" name="TextBox 5"/>
+      </p:pic>
+      <p:sp>
+        <p:nvSpPr>
+          <p:cNvPr id="5" name="TextBox 4"/>
           <p:cNvSpPr txBox="1"/>
           <p:nvPr/>
         </p:nvSpPr>
         <p:spPr>
           <a:xfrm>
-            <a:off x="731520" y="4937760"/>
-            <a:ext cx="10515600" cy="1371600"/>
+            <a:off x="8138160" y="1280160"/>
+            <a:ext cx="3840480" cy="5303520"/>
           </a:xfrm>
           <a:prstGeom prst="rect">
             <a:avLst/>
@@ -10907,15 +11263,15 @@
           <a:lstStyle/>
           <a:p>
             <a:pPr algn="l">
-              <a:defRPr sz="2200" b="1">
-                <a:solidFill>
-                  <a:srgbClr val="27AE60"/>
-                </a:solidFill>
-                <a:latin typeface="Calibri"/>
-              </a:defRPr>
-            </a:pPr>
-            <a:r>
-              <a:t>Destaque: Recon-PortScan F1 = 43.7%</a:t>
+              <a:defRPr sz="2000" b="1">
+                <a:solidFill>
+                  <a:srgbClr val="E74C3C"/>
+                </a:solidFill>
+                <a:latin typeface="Calibri"/>
+              </a:defRPr>
+            </a:pPr>
+            <a:r>
+              <a:t>Veredicto:</a:t>
             </a:r>
           </a:p>
           <a:p>
@@ -10923,15 +11279,15 @@
               <a:spcBef>
                 <a:spcPts val="600"/>
               </a:spcBef>
-              <a:defRPr sz="1600" b="0">
-                <a:solidFill>
-                  <a:srgbClr val="404040"/>
-                </a:solidFill>
-                <a:latin typeface="Calibri"/>
-              </a:defRPr>
-            </a:pPr>
-            <a:r>
-              <a:t>Melhor resultado não-supervisionado da dissertação (Recall 49.1%, Precision 39.4%)</a:t>
+              <a:defRPr sz="1800" b="1">
+                <a:solidFill>
+                  <a:srgbClr val="E74C3C"/>
+                </a:solidFill>
+                <a:latin typeface="Calibri"/>
+              </a:defRPr>
+            </a:pPr>
+            <a:r>
+              <a:t>Original INUTILIZÁVEL</a:t>
             </a:r>
           </a:p>
           <a:p>
@@ -10939,7 +11295,68 @@
               <a:spcBef>
                 <a:spcPts val="600"/>
               </a:spcBef>
-              <a:defRPr sz="1600" b="0">
+              <a:defRPr sz="600" b="0">
+                <a:solidFill>
+                  <a:srgbClr val="000000"/>
+                </a:solidFill>
+                <a:latin typeface="Calibri"/>
+              </a:defRPr>
+            </a:pPr>
+          </a:p>
+          <a:p>
+            <a:pPr algn="l">
+              <a:spcBef>
+                <a:spcPts val="600"/>
+              </a:spcBef>
+              <a:defRPr sz="1600" b="1">
+                <a:solidFill>
+                  <a:srgbClr val="1B3A5C"/>
+                </a:solidFill>
+                <a:latin typeface="Calibri"/>
+              </a:defRPr>
+            </a:pPr>
+            <a:r>
+              <a:t>FPR Benigno:</a:t>
+            </a:r>
+          </a:p>
+          <a:p>
+            <a:pPr algn="l">
+              <a:spcBef>
+                <a:spcPts val="600"/>
+              </a:spcBef>
+              <a:defRPr sz="1400" b="0">
+                <a:solidFill>
+                  <a:srgbClr val="27AE60"/>
+                </a:solidFill>
+                <a:latin typeface="Calibri"/>
+              </a:defRPr>
+            </a:pPr>
+            <a:r>
+              <a:t>Próprio: 3.9%</a:t>
+            </a:r>
+          </a:p>
+          <a:p>
+            <a:pPr algn="l">
+              <a:spcBef>
+                <a:spcPts val="600"/>
+              </a:spcBef>
+              <a:defRPr sz="1400" b="0">
+                <a:solidFill>
+                  <a:srgbClr val="E74C3C"/>
+                </a:solidFill>
+                <a:latin typeface="Calibri"/>
+              </a:defRPr>
+            </a:pPr>
+            <a:r>
+              <a:t>Original: 54.4%</a:t>
+            </a:r>
+          </a:p>
+          <a:p>
+            <a:pPr algn="l">
+              <a:spcBef>
+                <a:spcPts val="600"/>
+              </a:spcBef>
+              <a:defRPr sz="1300" b="0">
                 <a:solidFill>
                   <a:srgbClr val="404040"/>
                 </a:solidFill>
@@ -10947,7 +11364,161 @@
               </a:defRPr>
             </a:pPr>
             <a:r>
-              <a:t>Alternativa: r0=0.15 → Precision 56.7%, FPR apenas 4.2%, F1=42.0%</a:t>
+              <a:t>(14x pior)</a:t>
+            </a:r>
+          </a:p>
+          <a:p>
+            <a:pPr algn="l">
+              <a:spcBef>
+                <a:spcPts val="600"/>
+              </a:spcBef>
+              <a:defRPr sz="600" b="0">
+                <a:solidFill>
+                  <a:srgbClr val="000000"/>
+                </a:solidFill>
+                <a:latin typeface="Calibri"/>
+              </a:defRPr>
+            </a:pPr>
+          </a:p>
+          <a:p>
+            <a:pPr algn="l">
+              <a:spcBef>
+                <a:spcPts val="600"/>
+              </a:spcBef>
+              <a:defRPr sz="1600" b="1">
+                <a:solidFill>
+                  <a:srgbClr val="1B3A5C"/>
+                </a:solidFill>
+                <a:latin typeface="Calibri"/>
+              </a:defRPr>
+            </a:pPr>
+            <a:r>
+              <a:t>Causa raiz:</a:t>
+            </a:r>
+          </a:p>
+          <a:p>
+            <a:pPr algn="l">
+              <a:spcBef>
+                <a:spcPts val="600"/>
+              </a:spcBef>
+              <a:defRPr sz="1300" b="0">
+                <a:solidFill>
+                  <a:srgbClr val="404040"/>
+                </a:solidFill>
+                <a:latin typeface="Calibri"/>
+              </a:defRPr>
+            </a:pPr>
+            <a:r>
+              <a:t>Fórmula de variância diverge</a:t>
+            </a:r>
+          </a:p>
+          <a:p>
+            <a:pPr algn="l">
+              <a:spcBef>
+                <a:spcPts val="600"/>
+              </a:spcBef>
+              <a:defRPr sz="1300" b="0">
+                <a:solidFill>
+                  <a:srgbClr val="404040"/>
+                </a:solidFill>
+                <a:latin typeface="Calibri"/>
+              </a:defRPr>
+            </a:pPr>
+            <a:r>
+              <a:t>em 17 dimensões (projetado</a:t>
+            </a:r>
+          </a:p>
+          <a:p>
+            <a:pPr algn="l">
+              <a:spcBef>
+                <a:spcPts val="600"/>
+              </a:spcBef>
+              <a:defRPr sz="1300" b="0">
+                <a:solidFill>
+                  <a:srgbClr val="404040"/>
+                </a:solidFill>
+                <a:latin typeface="Calibri"/>
+              </a:defRPr>
+            </a:pPr>
+            <a:r>
+              <a:t>para datasets 2D sintéticos)</a:t>
+            </a:r>
+          </a:p>
+          <a:p>
+            <a:pPr algn="l">
+              <a:spcBef>
+                <a:spcPts val="600"/>
+              </a:spcBef>
+              <a:defRPr sz="600" b="0">
+                <a:solidFill>
+                  <a:srgbClr val="000000"/>
+                </a:solidFill>
+                <a:latin typeface="Calibri"/>
+              </a:defRPr>
+            </a:pPr>
+          </a:p>
+          <a:p>
+            <a:pPr algn="l">
+              <a:spcBef>
+                <a:spcPts val="600"/>
+              </a:spcBef>
+              <a:defRPr sz="1600" b="1">
+                <a:solidFill>
+                  <a:srgbClr val="27AE60"/>
+                </a:solidFill>
+                <a:latin typeface="Calibri"/>
+              </a:defRPr>
+            </a:pPr>
+            <a:r>
+              <a:t>Contribuição técnica:</a:t>
+            </a:r>
+          </a:p>
+          <a:p>
+            <a:pPr algn="l">
+              <a:spcBef>
+                <a:spcPts val="600"/>
+              </a:spcBef>
+              <a:defRPr sz="1300" b="0">
+                <a:solidFill>
+                  <a:srgbClr val="404040"/>
+                </a:solidFill>
+                <a:latin typeface="Calibri"/>
+              </a:defRPr>
+            </a:pPr>
+            <a:r>
+              <a:t>Adaptações (Welford, update</a:t>
+            </a:r>
+          </a:p>
+          <a:p>
+            <a:pPr algn="l">
+              <a:spcBef>
+                <a:spcPts val="600"/>
+              </a:spcBef>
+              <a:defRPr sz="1300" b="0">
+                <a:solidFill>
+                  <a:srgbClr val="404040"/>
+                </a:solidFill>
+                <a:latin typeface="Calibri"/>
+              </a:defRPr>
+            </a:pPr>
+            <a:r>
+              <a:t>seletivo, thresholds n=1/2)</a:t>
+            </a:r>
+          </a:p>
+          <a:p>
+            <a:pPr algn="l">
+              <a:spcBef>
+                <a:spcPts val="600"/>
+              </a:spcBef>
+              <a:defRPr sz="1400" b="1">
+                <a:solidFill>
+                  <a:srgbClr val="27AE60"/>
+                </a:solidFill>
+                <a:latin typeface="Calibri"/>
+              </a:defRPr>
+            </a:pPr>
+            <a:r>
+              <a:t>são NECESSÁRIAS para IoT IDS</a:t>
             </a:r>
           </a:p>
         </p:txBody>

</xml_diff>